<commit_message>
course(design): copyedit pass — title/em-dash house rules, connector attachment+direction fixes, conclusion-last builds, house-format speaker notes with ANIMATE cues
Co-Authored-By: Claude Opus 4.8 <noreply@anthropic.com>
</commit_message>
<xml_diff>
--- a/course/lectures/act-1-foundations/07-design/1-7-Design.pptx
+++ b/course/lectures/act-1-foundations/07-design/1-7-Design.pptx
@@ -534,6 +534,19 @@
           <a:p>
             <a:r>
               <a:rPr dirty="0"/>
+              <a:t xml:space="preserve">1.5 minutes — </a:t>
+            </a:r>
+            <a:r>
+              <a:rPr i="1" dirty="0"/>
+              <a:t>Make the handoff: Architecture assigned each part a responsibility; today we ask how a part realizes it.</a:t>
+            </a:r>
+          </a:p>
+          <a:p>
+            <a:endParaRPr dirty="0"/>
+          </a:p>
+          <a:p>
+            <a:r>
+              <a:rPr dirty="0"/>
               <a:t>Last time we chose how one acceptable system should be organized. We ended with major parts, boundaries, responsibilities, interfaces, and rules governing interaction.</a:t>
             </a:r>
           </a:p>
@@ -608,6 +621,19 @@
           <a:p>
             <a:r>
               <a:rPr dirty="0"/>
+              <a:t xml:space="preserve">20 seconds — </a:t>
+            </a:r>
+            <a:r>
+              <a:rPr i="1" dirty="0"/>
+              <a:t>Name Section 2: the same modeling discipline at a finer scope.</a:t>
+            </a:r>
+          </a:p>
+          <a:p>
+            <a:endParaRPr dirty="0"/>
+          </a:p>
+          <a:p>
+            <a:r>
+              <a:rPr dirty="0"/>
               <a:t>Section divider and callback. Specification and Architecture already taught purposeful modeling; Design uses the same discipline at a finer scope.</a:t>
             </a:r>
           </a:p>
@@ -664,6 +690,19 @@
           <a:p>
             <a:r>
               <a:rPr dirty="0"/>
+              <a:t xml:space="preserve">2 minutes — </a:t>
+            </a:r>
+            <a:r>
+              <a:rPr i="1" dirty="0"/>
+              <a:t>Answer a behavioral question with a behavioral model of one concrete component.</a:t>
+            </a:r>
+          </a:p>
+          <a:p>
+            <a:endParaRPr dirty="0"/>
+          </a:p>
+          <a:p>
+            <a:r>
+              <a:rPr dirty="0"/>
               <a:t>Behavioral model. Use a concrete component and a small state/transition model to answer a real internal question.</a:t>
             </a:r>
           </a:p>
@@ -729,6 +768,19 @@
           <a:p>
             <a:r>
               <a:rPr dirty="0"/>
+              <a:t xml:space="preserve">1.5 minutes — </a:t>
+            </a:r>
+            <a:r>
+              <a:rPr i="1" dirty="0"/>
+              <a:t>Show an ownership question forcing a different reduction of the same component.</a:t>
+            </a:r>
+          </a:p>
+          <a:p>
+            <a:endParaRPr dirty="0"/>
+          </a:p>
+          <a:p>
+            <a:r>
+              <a:rPr dirty="0"/>
               <a:t>Ownership model. Show that lifecycle, concurrency, cleanup, and failure questions require a different reduction of the same component.</a:t>
             </a:r>
           </a:p>
@@ -794,6 +846,19 @@
           <a:p>
             <a:r>
               <a:rPr dirty="0"/>
+              <a:t xml:space="preserve">1.5 minutes — </a:t>
+            </a:r>
+            <a:r>
+              <a:rPr i="1" dirty="0"/>
+              <a:t>Answer a change question with a structural model of the same component.</a:t>
+            </a:r>
+          </a:p>
+          <a:p>
+            <a:endParaRPr dirty="0"/>
+          </a:p>
+          <a:p>
+            <a:r>
+              <a:rPr dirty="0"/>
               <a:t>Structural model. Make change locality and internal coupling analyzable.</a:t>
             </a:r>
           </a:p>
@@ -859,6 +924,19 @@
           <a:p>
             <a:r>
               <a:rPr dirty="0"/>
+              <a:t xml:space="preserve">1.5 minutes — </a:t>
+            </a:r>
+            <a:r>
+              <a:rPr i="1" dirty="0"/>
+              <a:t>Answer a quantitative question with a measurement model instead of hand-waving.</a:t>
+            </a:r>
+          </a:p>
+          <a:p>
+            <a:endParaRPr dirty="0"/>
+          </a:p>
+          <a:p>
+            <a:r>
+              <a:rPr dirty="0"/>
               <a:t>Measurement model. Make one resource/performance bound explicit rather than hand-waving “efficient.”</a:t>
             </a:r>
           </a:p>
@@ -933,6 +1011,19 @@
           <a:p>
             <a:r>
               <a:rPr dirty="0"/>
+              <a:t xml:space="preserve">1.5 minutes — </a:t>
+            </a:r>
+            <a:r>
+              <a:rPr i="1" dirty="0"/>
+              <a:t>Synthesize: the question determines the reduction; a model earns its place by what it settles.</a:t>
+            </a:r>
+          </a:p>
+          <a:p>
+            <a:endParaRPr dirty="0"/>
+          </a:p>
+          <a:p>
+            <a:r>
+              <a:rPr dirty="0"/>
               <a:t>Same component. Four representations.</a:t>
             </a:r>
           </a:p>
@@ -1007,6 +1098,19 @@
           <a:p>
             <a:r>
               <a:rPr dirty="0"/>
+              <a:t xml:space="preserve">20 seconds — </a:t>
+            </a:r>
+            <a:r>
+              <a:rPr i="1" dirty="0"/>
+              <a:t>Name Section 3: recurring questions with alternatives and consequences, not a catalogue.</a:t>
+            </a:r>
+          </a:p>
+          <a:p>
+            <a:endParaRPr dirty="0"/>
+          </a:p>
+          <a:p>
+            <a:r>
+              <a:rPr dirty="0"/>
               <a:t>Section divider. We are not introducing “best practices”; we are identifying recurring engineering questions with alternative answers and consequences.</a:t>
             </a:r>
           </a:p>
@@ -1063,6 +1167,19 @@
           <a:p>
             <a:r>
               <a:rPr dirty="0"/>
+              <a:t xml:space="preserve">2 minutes — </a:t>
+            </a:r>
+            <a:r>
+              <a:rPr i="1" dirty="0"/>
+              <a:t>Establish authority: when representations disagree, exactly one must win.</a:t>
+            </a:r>
+          </a:p>
+          <a:p>
+            <a:endParaRPr dirty="0"/>
+          </a:p>
+          <a:p>
+            <a:r>
+              <a:rPr dirty="0"/>
               <a:t>Authority. When representations disagree, which one wins?</a:t>
             </a:r>
           </a:p>
@@ -1137,6 +1254,19 @@
           <a:p>
             <a:r>
               <a:rPr dirty="0"/>
+              <a:t xml:space="preserve">2 minutes — </a:t>
+            </a:r>
+            <a:r>
+              <a:rPr i="1" dirty="0"/>
+              <a:t>Show that required observation semantics, not replication topology, determine consistency.</a:t>
+            </a:r>
+          </a:p>
+          <a:p>
+            <a:endParaRPr dirty="0"/>
+          </a:p>
+          <a:p>
+            <a:r>
+              <a:rPr dirty="0"/>
               <a:t>Once state exists in multiple places, ask what clients must actually observe.</a:t>
             </a:r>
           </a:p>
@@ -1211,6 +1341,19 @@
           <a:p>
             <a:r>
               <a:rPr dirty="0"/>
+              <a:t xml:space="preserve">2 minutes — </a:t>
+            </a:r>
+            <a:r>
+              <a:rPr i="1" dirty="0"/>
+              <a:t>Contrast immediate and deferred work and the concerns each side takes on.</a:t>
+            </a:r>
+          </a:p>
+          <a:p>
+            <a:endParaRPr dirty="0"/>
+          </a:p>
+          <a:p>
+            <a:r>
+              <a:rPr dirty="0"/>
               <a:t>Immediate versus deferred work. Expose the consequences for latency, ordering, failure handling, retries, and idempotence.</a:t>
             </a:r>
           </a:p>
@@ -1276,6 +1419,19 @@
           <a:p>
             <a:r>
               <a:rPr dirty="0"/>
+              <a:t xml:space="preserve">1.5 minutes — </a:t>
+            </a:r>
+            <a:r>
+              <a:rPr i="1" dirty="0"/>
+              <a:t>Pose the recursive puzzle: opening boxes reveals more boxes, until the entities are small enough to reason about directly.</a:t>
+            </a:r>
+          </a:p>
+          <a:p>
+            <a:endParaRPr dirty="0"/>
+          </a:p>
+          <a:p>
+            <a:r>
+              <a:rPr dirty="0"/>
               <a:t>There is an immediate problem with saying Design works “inside the box.”</a:t>
             </a:r>
           </a:p>
@@ -1322,6 +1478,15 @@
             <a:r>
               <a:rPr dirty="0"/>
               <a:t>We can keep doing this.</a:t>
+            </a:r>
+          </a:p>
+          <a:p>
+            <a:endParaRPr dirty="0"/>
+          </a:p>
+          <a:p>
+            <a:r>
+              <a:rPr dirty="0"/>
+              <a:t>ANIMATE</a:t>
             </a:r>
           </a:p>
           <a:p>
@@ -1395,6 +1560,19 @@
           <a:p>
             <a:r>
               <a:rPr dirty="0"/>
+              <a:t xml:space="preserve">2.5 minutes — </a:t>
+            </a:r>
+            <a:r>
+              <a:rPr i="1" dirty="0"/>
+              <a:t>Show what indirection buys and the complexity it spends.</a:t>
+            </a:r>
+          </a:p>
+          <a:p>
+            <a:endParaRPr dirty="0"/>
+          </a:p>
+          <a:p>
+            <a:r>
+              <a:rPr dirty="0"/>
               <a:t>Indirection. Fundamental-theorem territory. Direct dependency versus an additional level of indirection; what isolation and substitution buy, and what complexity they cost.</a:t>
             </a:r>
           </a:p>
@@ -1469,6 +1647,19 @@
           <a:p>
             <a:r>
               <a:rPr dirty="0"/>
+              <a:t xml:space="preserve">2.5 minutes — </a:t>
+            </a:r>
+            <a:r>
+              <a:rPr i="1" dirty="0"/>
+              <a:t>Land information hiding: decompose around the decisions most likely to change.</a:t>
+            </a:r>
+          </a:p>
+          <a:p>
+            <a:endParaRPr dirty="0"/>
+          </a:p>
+          <a:p>
+            <a:r>
+              <a:rPr dirty="0"/>
               <a:t>This is where Parnas lands.</a:t>
             </a:r>
           </a:p>
@@ -1543,6 +1734,19 @@
           <a:p>
             <a:r>
               <a:rPr dirty="0"/>
+              <a:t xml:space="preserve">1.5 minutes — </a:t>
+            </a:r>
+            <a:r>
+              <a:rPr i="1" dirty="0"/>
+              <a:t>Synthesize the recurring choices as tradeoffs, not good-versus-bad answers.</a:t>
+            </a:r>
+          </a:p>
+          <a:p>
+            <a:endParaRPr dirty="0"/>
+          </a:p>
+          <a:p>
+            <a:r>
+              <a:rPr dirty="0"/>
               <a:t>Synthesis table. Recurring question → plausible alternatives → property/tradeoff.</a:t>
             </a:r>
           </a:p>
@@ -1608,6 +1812,19 @@
           <a:p>
             <a:r>
               <a:rPr dirty="0"/>
+              <a:t xml:space="preserve">2.5 minutes — </a:t>
+            </a:r>
+            <a:r>
+              <a:rPr i="1" dirty="0"/>
+              <a:t>Pay off the wall: Design tests whether the architectural strategy is workable.</a:t>
+            </a:r>
+          </a:p>
+          <a:p>
+            <a:endParaRPr dirty="0"/>
+          </a:p>
+          <a:p>
+            <a:r>
+              <a:rPr dirty="0"/>
               <a:t>Remember this wall from Architecture. At the time, we deliberately did not draw the plumbing.</a:t>
             </a:r>
           </a:p>
@@ -1727,7 +1944,29 @@
           <a:p>
             <a:r>
               <a:rPr dirty="0"/>
+              <a:t xml:space="preserve">2 minutes — </a:t>
+            </a:r>
+            <a:r>
+              <a:rPr i="1" dirty="0"/>
+              <a:t>Show an apparent local freedom with no satisfactory local answer becoming an architectural question.</a:t>
+            </a:r>
+          </a:p>
+          <a:p>
+            <a:endParaRPr dirty="0"/>
+          </a:p>
+          <a:p>
+            <a:r>
+              <a:rPr dirty="0"/>
               <a:t>Architecture did not specify whether this interaction was synchronous or asynchronous. At first glance, that looks like a legitimate Design freedom.</a:t>
+            </a:r>
+          </a:p>
+          <a:p>
+            <a:endParaRPr dirty="0"/>
+          </a:p>
+          <a:p>
+            <a:r>
+              <a:rPr dirty="0"/>
+              <a:t>ANIMATE</a:t>
             </a:r>
           </a:p>
           <a:p>
@@ -1745,7 +1984,25 @@
           <a:p>
             <a:r>
               <a:rPr dirty="0"/>
+              <a:t>ANIMATE</a:t>
+            </a:r>
+          </a:p>
+          <a:p>
+            <a:endParaRPr dirty="0"/>
+          </a:p>
+          <a:p>
+            <a:r>
+              <a:rPr dirty="0"/>
               <a:t>We try asynchronous. Now we cannot satisfy the consistency semantics the Specification requires.</a:t>
+            </a:r>
+          </a:p>
+          <a:p>
+            <a:endParaRPr dirty="0"/>
+          </a:p>
+          <a:p>
+            <a:r>
+              <a:rPr dirty="0"/>
+              <a:t>ANIMATE</a:t>
             </a:r>
           </a:p>
           <a:p>
@@ -1755,6 +2012,15 @@
             <a:r>
               <a:rPr dirty="0"/>
               <a:t>The important discovery is not that the designer needs a cleverer library. It is that the apparent degree of freedom was consequential.</a:t>
+            </a:r>
+          </a:p>
+          <a:p>
+            <a:endParaRPr dirty="0"/>
+          </a:p>
+          <a:p>
+            <a:r>
+              <a:rPr dirty="0"/>
+              <a:t>ANIMATE</a:t>
             </a:r>
           </a:p>
           <a:p>
@@ -1810,6 +2076,19 @@
           <a:p>
             <a:r>
               <a:rPr dirty="0"/>
+              <a:t xml:space="preserve">2 minutes — </a:t>
+            </a:r>
+            <a:r>
+              <a:rPr i="1" dirty="0"/>
+              <a:t>Show a local workaround making the architectural model false and its predictions wrong.</a:t>
+            </a:r>
+          </a:p>
+          <a:p>
+            <a:endParaRPr dirty="0"/>
+          </a:p>
+          <a:p>
+            <a:r>
+              <a:rPr dirty="0"/>
               <a:t>Here is the tempting alternative to escalation.</a:t>
             </a:r>
           </a:p>
@@ -1846,6 +2125,15 @@
           <a:p>
             <a:r>
               <a:rPr dirty="0"/>
+              <a:t>ANIMATE</a:t>
+            </a:r>
+          </a:p>
+          <a:p>
+            <a:endParaRPr dirty="0"/>
+          </a:p>
+          <a:p>
+            <a:r>
+              <a:rPr dirty="0"/>
               <a:t>And the architecture is now false.</a:t>
             </a:r>
           </a:p>
@@ -1865,6 +2153,15 @@
             <a:r>
               <a:rPr dirty="0"/>
               <a:t>Remember the Architecture lecture. We used dependency models to establish claims such as “no dependency crosses this boundary.” Once the implementation silently violates the model, that analysis can produce the wrong answer.</a:t>
+            </a:r>
+          </a:p>
+          <a:p>
+            <a:endParaRPr dirty="0"/>
+          </a:p>
+          <a:p>
+            <a:r>
+              <a:rPr dirty="0"/>
+              <a:t>ANIMATE</a:t>
             </a:r>
           </a:p>
           <a:p>
@@ -1938,7 +2235,29 @@
           <a:p>
             <a:r>
               <a:rPr dirty="0"/>
+              <a:t xml:space="preserve">1.5 minutes — </a:t>
+            </a:r>
+            <a:r>
+              <a:rPr i="1" dirty="0"/>
+              <a:t>Route consequential discoveries to Design, the environment, Architecture, or Specification; never silently ignore them.</a:t>
+            </a:r>
+          </a:p>
+          <a:p>
+            <a:endParaRPr dirty="0"/>
+          </a:p>
+          <a:p>
+            <a:r>
+              <a:rPr dirty="0"/>
               <a:t>Design is where many apparently free decisions first encounter reality.</a:t>
+            </a:r>
+          </a:p>
+          <a:p>
+            <a:endParaRPr dirty="0"/>
+          </a:p>
+          <a:p>
+            <a:r>
+              <a:rPr dirty="0"/>
+              <a:t>ANIMATE</a:t>
             </a:r>
           </a:p>
           <a:p>
@@ -1956,7 +2275,25 @@
           <a:p>
             <a:r>
               <a:rPr dirty="0"/>
+              <a:t>ANIMATE</a:t>
+            </a:r>
+          </a:p>
+          <a:p>
+            <a:endParaRPr dirty="0"/>
+          </a:p>
+          <a:p>
+            <a:r>
+              <a:rPr dirty="0"/>
               <a:t>Sometimes we discover that every component needs the same answer. That does not necessarily mean drawing another box on the architecture diagram. It may mean capturing a convention or mechanism in the engineering environment: every handler is idempotent; every external dependency goes through an adapter; every cross-boundary call carries a deadline.</a:t>
+            </a:r>
+          </a:p>
+          <a:p>
+            <a:endParaRPr dirty="0"/>
+          </a:p>
+          <a:p>
+            <a:r>
+              <a:rPr dirty="0"/>
+              <a:t>ANIMATE</a:t>
             </a:r>
           </a:p>
           <a:p>
@@ -1966,6 +2303,15 @@
             <a:r>
               <a:rPr dirty="0"/>
               <a:t>Sometimes the consequence is structural and belongs in Architecture.</a:t>
+            </a:r>
+          </a:p>
+          <a:p>
+            <a:endParaRPr dirty="0"/>
+          </a:p>
+          <a:p>
+            <a:r>
+              <a:rPr dirty="0"/>
+              <a:t>ANIMATE</a:t>
             </a:r>
           </a:p>
           <a:p>
@@ -2039,6 +2385,19 @@
           <a:p>
             <a:r>
               <a:rPr dirty="0"/>
+              <a:t xml:space="preserve">1 minute — </a:t>
+            </a:r>
+            <a:r>
+              <a:rPr i="1" dirty="0"/>
+              <a:t>Name Section 5: implementation itself can become a Design probe.</a:t>
+            </a:r>
+          </a:p>
+          <a:p>
+            <a:endParaRPr dirty="0"/>
+          </a:p>
+          <a:p>
+            <a:r>
+              <a:rPr dirty="0"/>
               <a:t>Architecture gave us a rule: if uncertainty could change the decision, consider buying information.</a:t>
             </a:r>
           </a:p>
@@ -2104,7 +2463,29 @@
           <a:p>
             <a:r>
               <a:rPr dirty="0"/>
+              <a:t xml:space="preserve">2 minutes — </a:t>
+            </a:r>
+            <a:r>
+              <a:rPr i="1" dirty="0"/>
+              <a:t>Show how temporal compression turns isolated incidents into evidence of structure.</a:t>
+            </a:r>
+          </a:p>
+          <a:p>
+            <a:endParaRPr dirty="0"/>
+          </a:p>
+          <a:p>
+            <a:r>
+              <a:rPr dirty="0"/>
               <a:t>At ordinary implementation speed, three related failures may occur weeks apart. Each one arrives with a local context and gets a local fix.</a:t>
+            </a:r>
+          </a:p>
+          <a:p>
+            <a:endParaRPr dirty="0"/>
+          </a:p>
+          <a:p>
+            <a:r>
+              <a:rPr dirty="0"/>
+              <a:t>ANIMATE</a:t>
             </a:r>
           </a:p>
           <a:p>
@@ -2178,6 +2559,19 @@
           <a:p>
             <a:r>
               <a:rPr dirty="0"/>
+              <a:t xml:space="preserve">2 minutes — </a:t>
+            </a:r>
+            <a:r>
+              <a:rPr i="1" dirty="0"/>
+              <a:t>Synthesize the economic and epistemic effects: velocity changes Design reasoning, not just speed.</a:t>
+            </a:r>
+          </a:p>
+          <a:p>
+            <a:endParaRPr dirty="0"/>
+          </a:p>
+          <a:p>
+            <a:r>
+              <a:rPr dirty="0"/>
               <a:t>In Architecture, GenAI lowered the cost of evidence about architectural alternatives.</a:t>
             </a:r>
           </a:p>
@@ -2196,7 +2590,25 @@
           <a:p>
             <a:r>
               <a:rPr dirty="0"/>
+              <a:t>ANIMATE</a:t>
+            </a:r>
+          </a:p>
+          <a:p>
+            <a:endParaRPr dirty="0"/>
+          </a:p>
+          <a:p>
+            <a:r>
+              <a:rPr dirty="0"/>
               <a:t>On the right, the obvious economic effect: we can afford to implement competing tactics, prototype a data structure, measure a coordination mechanism, or perform a refactoring that previously would have been too expensive merely to learn from.</a:t>
+            </a:r>
+          </a:p>
+          <a:p>
+            <a:endParaRPr dirty="0"/>
+          </a:p>
+          <a:p>
+            <a:r>
+              <a:rPr dirty="0"/>
+              <a:t>ANIMATE</a:t>
             </a:r>
           </a:p>
           <a:p>
@@ -2214,7 +2626,25 @@
           <a:p>
             <a:r>
               <a:rPr dirty="0"/>
+              <a:t>ANIMATE</a:t>
+            </a:r>
+          </a:p>
+          <a:p>
+            <a:endParaRPr dirty="0"/>
+          </a:p>
+          <a:p>
+            <a:r>
+              <a:rPr dirty="0"/>
               <a:t>Neither effect transfers judgment to the agent. It changes what evidence is economically available to the engineer.</a:t>
+            </a:r>
+          </a:p>
+          <a:p>
+            <a:endParaRPr dirty="0"/>
+          </a:p>
+          <a:p>
+            <a:r>
+              <a:rPr dirty="0"/>
+              <a:t>ANIMATE</a:t>
             </a:r>
           </a:p>
           <a:p>
@@ -2270,6 +2700,19 @@
           <a:p>
             <a:r>
               <a:rPr dirty="0"/>
+              <a:t xml:space="preserve">20 seconds — </a:t>
+            </a:r>
+            <a:r>
+              <a:rPr i="1" dirty="0"/>
+              <a:t>Name Section 1: Design does not begin from a blank page.</a:t>
+            </a:r>
+          </a:p>
+          <a:p>
+            <a:endParaRPr dirty="0"/>
+          </a:p>
+          <a:p>
+            <a:r>
+              <a:rPr dirty="0"/>
               <a:t>15–20 seconds only.</a:t>
             </a:r>
           </a:p>
@@ -2317,6 +2760,19 @@
           <a:p>
             <a:r>
               <a:rPr dirty="0"/>
+              <a:t xml:space="preserve">1 minute — </a:t>
+            </a:r>
+            <a:r>
+              <a:rPr i="1" dirty="0"/>
+              <a:t>Set up the exercise: one component, its inheritance, and the deliverable.</a:t>
+            </a:r>
+          </a:p>
+          <a:p>
+            <a:endParaRPr dirty="0"/>
+          </a:p>
+          <a:p>
+            <a:r>
+              <a:rPr dirty="0"/>
               <a:t>Explain the deliverable and immediately move.</a:t>
             </a:r>
           </a:p>
@@ -2373,6 +2829,19 @@
           <a:p>
             <a:r>
               <a:rPr dirty="0"/>
+              <a:t xml:space="preserve">3 minutes — </a:t>
+            </a:r>
+            <a:r>
+              <a:rPr i="1" dirty="0"/>
+              <a:t>Teams classify the remaining freedoms before answering any of them.</a:t>
+            </a:r>
+          </a:p>
+          <a:p>
+            <a:endParaRPr dirty="0"/>
+          </a:p>
+          <a:p>
+            <a:r>
+              <a:rPr dirty="0"/>
               <a:t>Teams identify remaining degrees of freedom and classify them FOLLOW / CHOOSE / ESCALATE. About 3 minutes.</a:t>
             </a:r>
           </a:p>
@@ -2438,6 +2907,19 @@
           <a:p>
             <a:r>
               <a:rPr dirty="0"/>
+              <a:t xml:space="preserve">7 minutes — </a:t>
+            </a:r>
+            <a:r>
+              <a:rPr i="1" dirty="0"/>
+              <a:t>Teams produce two genuinely different designs that respect what they inherited.</a:t>
+            </a:r>
+          </a:p>
+          <a:p>
+            <a:endParaRPr dirty="0"/>
+          </a:p>
+          <a:p>
+            <a:r>
+              <a:rPr dirty="0"/>
               <a:t>Force alternatives before convergence. Each needs a purposeful representation/model that supports a relevant claim. About 7 minutes.</a:t>
             </a:r>
           </a:p>
@@ -2512,6 +2994,19 @@
           <a:p>
             <a:r>
               <a:rPr dirty="0"/>
+              <a:t xml:space="preserve">6 minutes — </a:t>
+            </a:r>
+            <a:r>
+              <a:rPr i="1" dirty="0"/>
+              <a:t>Teams defend a choice against obligations, architecture, environment, and tradeoff.</a:t>
+            </a:r>
+          </a:p>
+          <a:p>
+            <a:endParaRPr dirty="0"/>
+          </a:p>
+          <a:p>
+            <a:r>
+              <a:rPr dirty="0"/>
               <a:t>Choose and defend: obligations, inherited architecture, environment, genuine tradeoff, evidence/model, anything that should feed upward.</a:t>
             </a:r>
           </a:p>
@@ -2568,6 +3063,19 @@
           <a:p>
             <a:r>
               <a:rPr dirty="0"/>
+              <a:t xml:space="preserve">4 minutes — </a:t>
+            </a:r>
+            <a:r>
+              <a:rPr i="1" dirty="0"/>
+              <a:t>Debrief: sort discoveries into follow, choose, environment, architecture, or specification.</a:t>
+            </a:r>
+          </a:p>
+          <a:p>
+            <a:endParaRPr dirty="0"/>
+          </a:p>
+          <a:p>
+            <a:r>
+              <a:rPr dirty="0"/>
               <a:t>Whole-room debrief. Which freedoms were genuinely local? Which were already answered? Which revealed a shared convention or an architectural/specification question? About 4 minutes.</a:t>
             </a:r>
           </a:p>
@@ -2633,6 +3141,19 @@
           <a:p>
             <a:r>
               <a:rPr dirty="0"/>
+              <a:t xml:space="preserve">1.5 minutes — </a:t>
+            </a:r>
+            <a:r>
+              <a:rPr i="1" dirty="0"/>
+              <a:t>Reconstruct the full progression: constraints flow down, evidence flows up.</a:t>
+            </a:r>
+          </a:p>
+          <a:p>
+            <a:endParaRPr dirty="0"/>
+          </a:p>
+          <a:p>
+            <a:r>
+              <a:rPr dirty="0"/>
               <a:t>We now have the complete downward progression.</a:t>
             </a:r>
           </a:p>
@@ -2743,6 +3264,19 @@
           <a:p>
             <a:r>
               <a:rPr dirty="0"/>
+              <a:t xml:space="preserve">45 seconds — </a:t>
+            </a:r>
+            <a:r>
+              <a:rPr i="1" dirty="0"/>
+              <a:t>Land the closing sentence and stop.</a:t>
+            </a:r>
+          </a:p>
+          <a:p>
+            <a:endParaRPr dirty="0"/>
+          </a:p>
+          <a:p>
+            <a:r>
+              <a:rPr dirty="0"/>
               <a:t>Architecture is strategy. Design is tactics.</a:t>
             </a:r>
           </a:p>
@@ -2835,6 +3369,19 @@
           <a:p>
             <a:r>
               <a:rPr dirty="0"/>
+              <a:t xml:space="preserve">1.5 minutes — </a:t>
+            </a:r>
+            <a:r>
+              <a:rPr i="1" dirty="0"/>
+              <a:t>Show that opening a box keeps its responsibility, interface, and obligations; only the internals become our problem.</a:t>
+            </a:r>
+          </a:p>
+          <a:p>
+            <a:endParaRPr dirty="0"/>
+          </a:p>
+          <a:p>
+            <a:r>
+              <a:rPr dirty="0"/>
               <a:t>Architecture deliberately let us ignore this component's internals. That compression was useful: we could reason about system-wide structure without simultaneously reasoning about every object and function.</a:t>
             </a:r>
           </a:p>
@@ -2872,6 +3419,15 @@
             <a:r>
               <a:rPr dirty="0"/>
               <a:t>What changes is that the inside is now our engineering problem.</a:t>
+            </a:r>
+          </a:p>
+          <a:p>
+            <a:endParaRPr dirty="0"/>
+          </a:p>
+          <a:p>
+            <a:r>
+              <a:rPr dirty="0"/>
+              <a:t>ANIMATE</a:t>
             </a:r>
           </a:p>
           <a:p>
@@ -2927,7 +3483,65 @@
           <a:p>
             <a:r>
               <a:rPr dirty="0"/>
-              <a:t>Two sources should now be familiar. The Specification tells us what must remain true. Architecture tells us what this part is responsible for and how it fits into the larger strategy.</a:t>
+              <a:t xml:space="preserve">2 minutes — </a:t>
+            </a:r>
+            <a:r>
+              <a:rPr i="1" dirty="0"/>
+              <a:t>Establish the three inherited sources of constraint, especially the engineering environment.</a:t>
+            </a:r>
+          </a:p>
+          <a:p>
+            <a:endParaRPr dirty="0"/>
+          </a:p>
+          <a:p>
+            <a:r>
+              <a:rPr dirty="0"/>
+              <a:t>Two sources should now be familiar.</a:t>
+            </a:r>
+          </a:p>
+          <a:p>
+            <a:endParaRPr dirty="0"/>
+          </a:p>
+          <a:p>
+            <a:r>
+              <a:rPr dirty="0"/>
+              <a:t>ANIMATE</a:t>
+            </a:r>
+          </a:p>
+          <a:p>
+            <a:endParaRPr dirty="0"/>
+          </a:p>
+          <a:p>
+            <a:r>
+              <a:rPr dirty="0"/>
+              <a:t>The Specification tells us what must remain true.</a:t>
+            </a:r>
+          </a:p>
+          <a:p>
+            <a:endParaRPr dirty="0"/>
+          </a:p>
+          <a:p>
+            <a:r>
+              <a:rPr dirty="0"/>
+              <a:t>ANIMATE</a:t>
+            </a:r>
+          </a:p>
+          <a:p>
+            <a:endParaRPr dirty="0"/>
+          </a:p>
+          <a:p>
+            <a:r>
+              <a:rPr dirty="0"/>
+              <a:t>Architecture tells us what this part is responsible for and how it fits into the larger strategy.</a:t>
+            </a:r>
+          </a:p>
+          <a:p>
+            <a:endParaRPr dirty="0"/>
+          </a:p>
+          <a:p>
+            <a:r>
+              <a:rPr dirty="0"/>
+              <a:t>ANIMATE</a:t>
             </a:r>
           </a:p>
           <a:p>
@@ -2946,6 +3560,15 @@
             <a:r>
               <a:rPr dirty="0"/>
               <a:t>Suppose this organization already says all persistent state goes through repositories. Or all dependencies are injected. Or cross-service calls carry deadlines. Or asynchronous work uses the standard queue with its standard retry and dead-letter behavior.</a:t>
+            </a:r>
+          </a:p>
+          <a:p>
+            <a:endParaRPr dirty="0"/>
+          </a:p>
+          <a:p>
+            <a:r>
+              <a:rPr dirty="0"/>
+              <a:t>ANIMATE</a:t>
             </a:r>
           </a:p>
           <a:p>
@@ -3010,6 +3633,19 @@
           <a:p>
             <a:r>
               <a:rPr dirty="0"/>
+              <a:t xml:space="preserve">1.5 minutes — </a:t>
+            </a:r>
+            <a:r>
+              <a:rPr i="1" dirty="0"/>
+              <a:t>Recast Design as the degrees of freedom remaining after inherited decisions constrain the space.</a:t>
+            </a:r>
+          </a:p>
+          <a:p>
+            <a:endParaRPr dirty="0"/>
+          </a:p>
+          <a:p>
+            <a:r>
+              <a:rPr dirty="0"/>
               <a:t>Remember Degrees of Freedom from Specification. Every consequential decision removes alternatives from the realization space.</a:t>
             </a:r>
           </a:p>
@@ -3093,7 +3729,38 @@
           <a:p>
             <a:r>
               <a:rPr dirty="0"/>
+              <a:t xml:space="preserve">2 minutes — </a:t>
+            </a:r>
+            <a:r>
+              <a:rPr i="1" dirty="0"/>
+              <a:t>Give Design its three moves: follow, choose, or escalate.</a:t>
+            </a:r>
+          </a:p>
+          <a:p>
+            <a:endParaRPr dirty="0"/>
+          </a:p>
+          <a:p>
+            <a:r>
+              <a:rPr dirty="0"/>
+              <a:t>ANIMATE</a:t>
+            </a:r>
+          </a:p>
+          <a:p>
+            <a:endParaRPr dirty="0"/>
+          </a:p>
+          <a:p>
+            <a:r>
+              <a:rPr dirty="0"/>
               <a:t>If the engineering environment already provides the retry mechanism, follow it. Reinventing retries inside this component is not Design creativity.</a:t>
+            </a:r>
+          </a:p>
+          <a:p>
+            <a:endParaRPr dirty="0"/>
+          </a:p>
+          <a:p>
+            <a:r>
+              <a:rPr dirty="0"/>
+              <a:t>ANIMATE</a:t>
             </a:r>
           </a:p>
           <a:p>
@@ -3103,6 +3770,15 @@
             <a:r>
               <a:rPr dirty="0"/>
               <a:t>If two internal data structures satisfy every inherited property and nothing outside this component cares, choose locally.</a:t>
+            </a:r>
+          </a:p>
+          <a:p>
+            <a:endParaRPr dirty="0"/>
+          </a:p>
+          <a:p>
+            <a:r>
+              <a:rPr dirty="0"/>
+              <a:t>ANIMATE</a:t>
             </a:r>
           </a:p>
           <a:p>
@@ -3167,6 +3843,19 @@
           <a:p>
             <a:r>
               <a:rPr dirty="0"/>
+              <a:t xml:space="preserve">1.5 minutes — </a:t>
+            </a:r>
+            <a:r>
+              <a:rPr i="1" dirty="0"/>
+              <a:t>Formalize strategy versus tactics, and make the distinction recursive rather than layered.</a:t>
+            </a:r>
+          </a:p>
+          <a:p>
+            <a:endParaRPr dirty="0"/>
+          </a:p>
+          <a:p>
+            <a:r>
+              <a:rPr dirty="0"/>
               <a:t>This gives us the cleanest relationship between the two activities.</a:t>
             </a:r>
           </a:p>
@@ -3247,6 +3936,19 @@
         <p:txBody>
           <a:bodyPr/>
           <a:lstStyle/>
+          <a:p>
+            <a:r>
+              <a:rPr dirty="0"/>
+              <a:t xml:space="preserve">1 minute — </a:t>
+            </a:r>
+            <a:r>
+              <a:rPr i="1" dirty="0"/>
+              <a:t>Resolve the recursion: stop when entities are directly reasonable; Design passes into Implementation.</a:t>
+            </a:r>
+          </a:p>
+          <a:p>
+            <a:endParaRPr dirty="0"/>
+          </a:p>
           <a:p>
             <a:r>
               <a:rPr dirty="0"/>
@@ -7538,7 +8240,7 @@
                   <a:srgbClr val="555960"/>
                 </a:solidFill>
               </a:rPr>
-              <a:t xml:space="preserve">   —   one component, one question</a:t>
+              <a:t xml:space="preserve">   ·   one component, one question</a:t>
             </a:r>
           </a:p>
         </p:txBody>
@@ -7982,19 +8684,61 @@
       </p:sp>
       <p:cxnSp>
         <p:nvCxnSpPr>
+          <p:cNvPr id="133" name="RetryDown"/>
+          <p:cNvCxnSpPr/>
+          <p:nvPr/>
+        </p:nvCxnSpPr>
+        <p:spPr>
+          <a:xfrm>
+            <a:off x="5900000" y="2800000"/>
+            <a:ext cx="0" cy="300000"/>
+          </a:xfrm>
+          <a:prstGeom prst="straightConnector1">
+            <a:avLst/>
+          </a:prstGeom>
+          <a:ln w="25400" cap="rnd">
+            <a:solidFill>
+              <a:srgbClr val="C0392B"/>
+            </a:solidFill>
+          </a:ln>
+        </p:spPr>
+      </p:cxnSp>
+      <p:cxnSp>
+        <p:nvCxnSpPr>
+          <p:cNvPr id="134" name="RetryAcross"/>
+          <p:cNvCxnSpPr/>
+          <p:nvPr/>
+        </p:nvCxnSpPr>
+        <p:spPr>
+          <a:xfrm>
+            <a:off x="1440000" y="3100000"/>
+            <a:ext cx="4460000" cy="0"/>
+          </a:xfrm>
+          <a:prstGeom prst="straightConnector1">
+            <a:avLst/>
+          </a:prstGeom>
+          <a:ln w="25400" cap="rnd">
+            <a:solidFill>
+              <a:srgbClr val="C0392B"/>
+            </a:solidFill>
+          </a:ln>
+        </p:spPr>
+      </p:cxnSp>
+      <p:cxnSp>
+        <p:nvCxnSpPr>
           <p:cNvPr id="130" name="Retry"/>
           <p:cNvCxnSpPr/>
           <p:nvPr/>
         </p:nvCxnSpPr>
         <p:spPr>
-          <a:xfrm flipH="1">
-            <a:off x="1990000" y="3320000"/>
-            <a:ext cx="3360000" cy="0"/>
+          <a:xfrm flipV="1">
+            <a:off x="1440000" y="2800000"/>
+            <a:ext cx="0" cy="300000"/>
           </a:xfrm>
           <a:prstGeom prst="straightConnector1">
             <a:avLst/>
           </a:prstGeom>
-          <a:ln w="19050">
+          <a:ln w="25400" cap="rnd">
             <a:solidFill>
               <a:srgbClr val="C0392B"/>
             </a:solidFill>
@@ -8010,8 +8754,8 @@
         </p:nvSpPr>
         <p:spPr>
           <a:xfrm>
-            <a:off x="1240000" y="3340000"/>
-            <a:ext cx="4200000" cy="260000"/>
+            <a:off x="2470000" y="3150000"/>
+            <a:ext cx="2400000" cy="190000"/>
           </a:xfrm>
           <a:prstGeom prst="rect">
             <a:avLst/>
@@ -8027,7 +8771,7 @@
           </a:bodyPr>
           <a:lstStyle/>
           <a:p>
-            <a:pPr algn="l">
+            <a:pPr algn="ctr">
               <a:buNone/>
             </a:pPr>
             <a:r>
@@ -8291,7 +9035,7 @@
                   <a:srgbClr val="555960"/>
                 </a:solidFill>
               </a:rPr>
-              <a:t xml:space="preserve">   —   one component, one question</a:t>
+              <a:t xml:space="preserve">   ·   one component, one question</a:t>
             </a:r>
           </a:p>
         </p:txBody>
@@ -8616,7 +9360,7 @@
         </p:nvSpPr>
         <p:spPr>
           <a:xfrm>
-            <a:off x="1300000" y="2892000"/>
+            <a:off x="1300000" y="2860000"/>
             <a:ext cx="6420000" cy="160000"/>
           </a:xfrm>
           <a:prstGeom prst="rect">
@@ -8686,7 +9430,7 @@
         </p:nvSpPr>
         <p:spPr>
           <a:xfrm>
-            <a:off x="1300000" y="3072000"/>
+            <a:off x="1300000" y="3030000"/>
             <a:ext cx="4740000" cy="160000"/>
           </a:xfrm>
           <a:prstGeom prst="rect">
@@ -8756,7 +9500,7 @@
         </p:nvSpPr>
         <p:spPr>
           <a:xfrm>
-            <a:off x="2980000" y="3252000"/>
+            <a:off x="2980000" y="3200000"/>
             <a:ext cx="4740000" cy="160000"/>
           </a:xfrm>
           <a:prstGeom prst="rect">
@@ -9037,7 +9781,7 @@
                   <a:srgbClr val="555960"/>
                 </a:solidFill>
               </a:rPr>
-              <a:t xml:space="preserve">   —   one component, one question</a:t>
+              <a:t xml:space="preserve">   ·   one component, one question</a:t>
             </a:r>
           </a:p>
         </p:txBody>
@@ -9644,7 +10388,7 @@
                   <a:srgbClr val="555960"/>
                 </a:solidFill>
               </a:rPr>
-              <a:t xml:space="preserve">   —   one component, one question</a:t>
+              <a:t xml:space="preserve">   ·   one component, one question</a:t>
             </a:r>
           </a:p>
         </p:txBody>
@@ -10094,8 +10838,8 @@
         </p:nvSpPr>
         <p:spPr>
           <a:xfrm>
-            <a:off x="1240000" y="3280000"/>
-            <a:ext cx="6540000" cy="380000"/>
+            <a:off x="1240000" y="3450000"/>
+            <a:ext cx="6540000" cy="260000"/>
           </a:xfrm>
           <a:prstGeom prst="roundRect">
             <a:avLst/>
@@ -11181,7 +11925,7 @@
                   <a:srgbClr val="555960"/>
                 </a:solidFill>
               </a:rPr>
-              <a:t>Recurring problem →</a:t>
+              <a:t>Recurring problem</a:t>
             </a:r>
           </a:p>
           <a:p>
@@ -11197,7 +11941,23 @@
                   <a:srgbClr val="555960"/>
                 </a:solidFill>
               </a:rPr>
-              <a:t>plausible alternatives → consequences</a:t>
+              <a:t>→ plausible alternatives</a:t>
+            </a:r>
+          </a:p>
+          <a:p>
+            <a:pPr algn="ctr">
+              <a:spcBef>
+                <a:spcPts val="120"/>
+              </a:spcBef>
+              <a:buNone/>
+            </a:pPr>
+            <a:r>
+              <a:rPr lang="en-US" sz="2800" b="0" i="0" dirty="0">
+                <a:solidFill>
+                  <a:srgbClr val="555960"/>
+                </a:solidFill>
+              </a:rPr>
+              <a:t>→ consequences</a:t>
             </a:r>
           </a:p>
         </p:txBody>
@@ -11509,8 +12269,8 @@
         </p:nvSpPr>
         <p:spPr>
           <a:xfrm>
-            <a:off x="685800" y="6200000"/>
-            <a:ext cx="7772400" cy="340000"/>
+            <a:off x="277148" y="4000000"/>
+            <a:ext cx="8589704" cy="360000"/>
           </a:xfrm>
           <a:prstGeom prst="rect">
             <a:avLst/>
@@ -11530,7 +12290,7 @@
               <a:buNone/>
             </a:pPr>
             <a:r>
-              <a:rPr lang="en-US" sz="1500" b="0" i="1" dirty="0">
+              <a:rPr lang="en-US" sz="1700" b="0" i="1" dirty="0">
                 <a:solidFill>
                   <a:srgbClr val="000000"/>
                 </a:solidFill>
@@ -14695,7 +15455,7 @@
                   <a:srgbClr val="8E6F3E"/>
                 </a:solidFill>
               </a:rPr>
-              <a:t>A — by processing steps</a:t>
+              <a:t>A: by processing steps</a:t>
             </a:r>
           </a:p>
         </p:txBody>
@@ -14809,7 +15569,7 @@
                   <a:srgbClr val="8E6F3E"/>
                 </a:solidFill>
               </a:rPr>
-              <a:t>B — around likely change</a:t>
+              <a:t>B: around likely change</a:t>
             </a:r>
           </a:p>
         </p:txBody>
@@ -15565,7 +16325,7 @@
                   <a:srgbClr val="000000"/>
                 </a:solidFill>
               </a:rPr>
-              <a:t>coordination / avail.-latency</a:t>
+              <a:t>coordination / availability-latency</a:t>
             </a:r>
           </a:p>
         </p:txBody>
@@ -16872,7 +17632,7 @@
                   <a:srgbClr val="555960"/>
                 </a:solidFill>
               </a:rPr>
-              <a:t>information about the strategy — not just a plumbing failure</a:t>
+              <a:t>information about the strategy, not just a plumbing failure</a:t>
             </a:r>
           </a:p>
         </p:txBody>
@@ -17556,7 +18316,7 @@
 </file>
 
 <file path=ppt/slides/slide24.xml><?xml version="1.0" encoding="utf-8"?>
-<p:sld xmlns:a="http://schemas.openxmlformats.org/drawingml/2006/main" xmlns:r="http://schemas.openxmlformats.org/officeDocument/2006/relationships" xmlns:p="http://schemas.openxmlformats.org/presentationml/2006/main">
+<p:sld xmlns:a="http://schemas.openxmlformats.org/drawingml/2006/main" xmlns:p="http://schemas.openxmlformats.org/presentationml/2006/main">
   <p:cSld>
     <p:spTree>
       <p:nvGrpSpPr>
@@ -17945,9 +18705,9 @@
           <p:nvPr/>
         </p:nvCxnSpPr>
         <p:spPr>
-          <a:xfrm flipV="1">
-            <a:off x="4572000" y="3780000"/>
-            <a:ext cx="0" cy="300000"/>
+          <a:xfrm>
+            <a:off x="4572000" y="3760000"/>
+            <a:ext cx="0" cy="370000"/>
           </a:xfrm>
           <a:prstGeom prst="straightConnector1">
             <a:avLst/>
@@ -18310,6 +19070,50 @@
                             </p:childTnLst>
                           </p:cTn>
                         </p:par>
+                        <p:par>
+                          <p:cTn id="27" fill="hold">
+                            <p:stCondLst>
+                              <p:cond delay="0"/>
+                            </p:stCondLst>
+                            <p:childTnLst>
+                              <p:par>
+                                <p:cTn id="28" presetID="10" presetClass="entr" presetSubtype="0" fill="hold" grpId="5" nodeType="withEffect">
+                                  <p:stCondLst>
+                                    <p:cond delay="0"/>
+                                  </p:stCondLst>
+                                  <p:childTnLst>
+                                    <p:set>
+                                      <p:cBhvr>
+                                        <p:cTn id="29" dur="1" fill="hold">
+                                          <p:stCondLst>
+                                            <p:cond delay="0"/>
+                                          </p:stCondLst>
+                                        </p:cTn>
+                                        <p:tgtEl>
+                                          <p:spTgt spid="109"/>
+                                        </p:tgtEl>
+                                        <p:attrNameLst>
+                                          <p:attrName>style.visibility</p:attrName>
+                                        </p:attrNameLst>
+                                      </p:cBhvr>
+                                      <p:to>
+                                        <p:strVal val="visible"/>
+                                      </p:to>
+                                    </p:set>
+                                    <p:animEffect transition="in" filter="fade">
+                                      <p:cBhvr>
+                                        <p:cTn id="30" dur="500"/>
+                                        <p:tgtEl>
+                                          <p:spTgt spid="109"/>
+                                        </p:tgtEl>
+                                      </p:cBhvr>
+                                    </p:animEffect>
+                                  </p:childTnLst>
+                                </p:cTn>
+                              </p:par>
+                            </p:childTnLst>
+                          </p:cTn>
+                        </p:par>
                       </p:childTnLst>
                     </p:cTn>
                   </p:par>
@@ -18340,13 +19144,14 @@
       <p:bldP spid="106" grpId="2"/>
       <p:bldP spid="107" grpId="3"/>
       <p:bldP spid="108" grpId="4"/>
+      <p:bldP spid="109" grpId="5"/>
     </p:bldLst>
   </p:timing>
 </p:sld>
 </file>
 
 <file path=ppt/slides/slide25.xml><?xml version="1.0" encoding="utf-8"?>
-<p:sld xmlns:a="http://schemas.openxmlformats.org/drawingml/2006/main" xmlns:r="http://schemas.openxmlformats.org/officeDocument/2006/relationships" xmlns:p="http://schemas.openxmlformats.org/presentationml/2006/main">
+<p:sld xmlns:a="http://schemas.openxmlformats.org/drawingml/2006/main" xmlns:p="http://schemas.openxmlformats.org/presentationml/2006/main">
   <p:cSld>
     <p:spTree>
       <p:nvGrpSpPr>
@@ -18967,6 +19772,50 @@
                             </p:childTnLst>
                           </p:cTn>
                         </p:par>
+                        <p:par>
+                          <p:cTn id="22" fill="hold">
+                            <p:stCondLst>
+                              <p:cond delay="0"/>
+                            </p:stCondLst>
+                            <p:childTnLst>
+                              <p:par>
+                                <p:cTn id="23" presetID="10" presetClass="entr" presetSubtype="0" fill="hold" grpId="4" nodeType="withEffect">
+                                  <p:stCondLst>
+                                    <p:cond delay="0"/>
+                                  </p:stCondLst>
+                                  <p:childTnLst>
+                                    <p:set>
+                                      <p:cBhvr>
+                                        <p:cTn id="24" dur="1" fill="hold">
+                                          <p:stCondLst>
+                                            <p:cond delay="0"/>
+                                          </p:stCondLst>
+                                        </p:cTn>
+                                        <p:tgtEl>
+                                          <p:spTgt spid="106"/>
+                                        </p:tgtEl>
+                                        <p:attrNameLst>
+                                          <p:attrName>style.visibility</p:attrName>
+                                        </p:attrNameLst>
+                                      </p:cBhvr>
+                                      <p:to>
+                                        <p:strVal val="visible"/>
+                                      </p:to>
+                                    </p:set>
+                                    <p:animEffect transition="in" filter="fade">
+                                      <p:cBhvr>
+                                        <p:cTn id="25" dur="500"/>
+                                        <p:tgtEl>
+                                          <p:spTgt spid="106"/>
+                                        </p:tgtEl>
+                                      </p:cBhvr>
+                                    </p:animEffect>
+                                  </p:childTnLst>
+                                </p:cTn>
+                              </p:par>
+                            </p:childTnLst>
+                          </p:cTn>
+                        </p:par>
                       </p:childTnLst>
                     </p:cTn>
                   </p:par>
@@ -18996,6 +19845,7 @@
       <p:bldP spid="103" grpId="1"/>
       <p:bldP spid="104" grpId="2"/>
       <p:bldP spid="105" grpId="3"/>
+      <p:bldP spid="106" grpId="4"/>
     </p:bldLst>
   </p:timing>
 </p:sld>
@@ -19648,7 +20498,7 @@
                   <a:srgbClr val="FFFFFF"/>
                 </a:solidFill>
               </a:rPr>
-              <a:t>REMOVE IT  ·  MODEL IT  ·  CHANGE THE RULE   —   never silently ignore it</a:t>
+              <a:t>REMOVE IT  ·  MODEL IT  ·  CHANGE THE RULE.  Never silently ignore it.</a:t>
             </a:r>
           </a:p>
         </p:txBody>
@@ -20343,8 +21193,8 @@
         </p:nvSpPr>
         <p:spPr>
           <a:xfrm>
-            <a:off x="685800" y="2240280"/>
-            <a:ext cx="7772400" cy="914400"/>
+            <a:off x="277148" y="2240280"/>
+            <a:ext cx="8589704" cy="914400"/>
           </a:xfrm>
         </p:spPr>
         <p:txBody>
@@ -20358,7 +21208,7 @@
               <a:defRPr b="0"/>
             </a:pPr>
             <a:r>
-              <a:rPr lang="en-US" sz="3600" b="0" i="0" dirty="0">
+              <a:rPr lang="en-US" sz="3400" b="0" i="0" dirty="0">
                 <a:solidFill>
                   <a:srgbClr val="000000"/>
                 </a:solidFill>
@@ -20469,8 +21319,8 @@
         </p:nvSpPr>
         <p:spPr>
           <a:xfrm>
-            <a:off x="1371600" y="3900000"/>
-            <a:ext cx="6400800" cy="1400000"/>
+            <a:off x="685800" y="3900000"/>
+            <a:ext cx="7772400" cy="1400000"/>
           </a:xfrm>
           <a:prstGeom prst="rect">
             <a:avLst/>
@@ -20745,7 +21595,7 @@
 </file>
 
 <file path=ppt/slides/slide28.xml><?xml version="1.0" encoding="utf-8"?>
-<p:sld xmlns:a="http://schemas.openxmlformats.org/drawingml/2006/main" xmlns:r="http://schemas.openxmlformats.org/officeDocument/2006/relationships" xmlns:p="http://schemas.openxmlformats.org/presentationml/2006/main">
+<p:sld xmlns:a="http://schemas.openxmlformats.org/drawingml/2006/main" xmlns:p="http://schemas.openxmlformats.org/presentationml/2006/main">
   <p:cSld>
     <p:spTree>
       <p:nvGrpSpPr>
@@ -20898,7 +21748,7 @@
                   <a:srgbClr val="000000"/>
                 </a:solidFill>
               </a:rPr>
-              <a:t>FAIL A — fix — local        FAIL B — fix — local        FAIL C — fix — local</a:t>
+              <a:t>FAIL A → fix → local        FAIL B → fix → local        FAIL C → fix → local</a:t>
             </a:r>
           </a:p>
           <a:p>
@@ -20996,7 +21846,7 @@
                   <a:srgbClr val="000000"/>
                 </a:solidFill>
               </a:rPr>
-              <a:t>A   B   C     — in dense succession</a:t>
+              <a:t>A   B   C     ·   in dense succession</a:t>
             </a:r>
           </a:p>
           <a:p>
@@ -21181,6 +22031,50 @@
                             </p:childTnLst>
                           </p:cTn>
                         </p:par>
+                        <p:par>
+                          <p:cTn id="12" fill="hold">
+                            <p:stCondLst>
+                              <p:cond delay="0"/>
+                            </p:stCondLst>
+                            <p:childTnLst>
+                              <p:par>
+                                <p:cTn id="13" presetID="10" presetClass="entr" presetSubtype="0" fill="hold" grpId="2" nodeType="withEffect">
+                                  <p:stCondLst>
+                                    <p:cond delay="0"/>
+                                  </p:stCondLst>
+                                  <p:childTnLst>
+                                    <p:set>
+                                      <p:cBhvr>
+                                        <p:cTn id="14" dur="1" fill="hold">
+                                          <p:stCondLst>
+                                            <p:cond delay="0"/>
+                                          </p:stCondLst>
+                                        </p:cTn>
+                                        <p:tgtEl>
+                                          <p:spTgt spid="104"/>
+                                        </p:tgtEl>
+                                        <p:attrNameLst>
+                                          <p:attrName>style.visibility</p:attrName>
+                                        </p:attrNameLst>
+                                      </p:cBhvr>
+                                      <p:to>
+                                        <p:strVal val="visible"/>
+                                      </p:to>
+                                    </p:set>
+                                    <p:animEffect transition="in" filter="fade">
+                                      <p:cBhvr>
+                                        <p:cTn id="15" dur="500"/>
+                                        <p:tgtEl>
+                                          <p:spTgt spid="104"/>
+                                        </p:tgtEl>
+                                      </p:cBhvr>
+                                    </p:animEffect>
+                                  </p:childTnLst>
+                                </p:cTn>
+                              </p:par>
+                            </p:childTnLst>
+                          </p:cTn>
+                        </p:par>
                       </p:childTnLst>
                     </p:cTn>
                   </p:par>
@@ -21208,13 +22102,14 @@
     <p:bldLst>
       <p:bldP spid="102" grpId="0"/>
       <p:bldP spid="103" grpId="1"/>
+      <p:bldP spid="104" grpId="2"/>
     </p:bldLst>
   </p:timing>
 </p:sld>
 </file>
 
 <file path=ppt/slides/slide29.xml><?xml version="1.0" encoding="utf-8"?>
-<p:sld xmlns:a="http://schemas.openxmlformats.org/drawingml/2006/main" xmlns:r="http://schemas.openxmlformats.org/officeDocument/2006/relationships" xmlns:p="http://schemas.openxmlformats.org/presentationml/2006/main">
+<p:sld xmlns:a="http://schemas.openxmlformats.org/drawingml/2006/main" xmlns:p="http://schemas.openxmlformats.org/presentationml/2006/main">
   <p:cSld>
     <p:spTree>
       <p:nvGrpSpPr>
@@ -21262,7 +22157,7 @@
                   <a:srgbClr val="000000"/>
                 </a:solidFill>
               </a:rPr>
-              <a:t>MAGE Moment — Velocity changes Design reasoning</a:t>
+              <a:t>MAGE Moment: Velocity changes Design reasoning</a:t>
             </a:r>
           </a:p>
         </p:txBody>
@@ -21649,6 +22544,103 @@
             <p:seq concurrent="1" nextAc="seek">
               <p:cTn id="2" dur="indefinite" nodeType="mainSeq">
                 <p:childTnLst>
+                  <p:par>
+                    <p:cTn id="12" fill="hold">
+                      <p:stCondLst>
+                        <p:cond delay="indefinite"/>
+                      </p:stCondLst>
+                      <p:childTnLst>
+                        <p:par>
+                          <p:cTn id="13" fill="hold">
+                            <p:stCondLst>
+                              <p:cond delay="0"/>
+                            </p:stCondLst>
+                            <p:childTnLst>
+                              <p:par>
+                                <p:cTn id="14" presetID="10" presetClass="entr" presetSubtype="0" fill="hold" grpId="2" nodeType="clickEffect">
+                                  <p:stCondLst>
+                                    <p:cond delay="0"/>
+                                  </p:stCondLst>
+                                  <p:childTnLst>
+                                    <p:set>
+                                      <p:cBhvr>
+                                        <p:cTn id="15" dur="1" fill="hold">
+                                          <p:stCondLst>
+                                            <p:cond delay="0"/>
+                                          </p:stCondLst>
+                                        </p:cTn>
+                                        <p:tgtEl>
+                                          <p:spTgt spid="102"/>
+                                        </p:tgtEl>
+                                        <p:attrNameLst>
+                                          <p:attrName>style.visibility</p:attrName>
+                                        </p:attrNameLst>
+                                      </p:cBhvr>
+                                      <p:to>
+                                        <p:strVal val="visible"/>
+                                      </p:to>
+                                    </p:set>
+                                    <p:animEffect transition="in" filter="fade">
+                                      <p:cBhvr>
+                                        <p:cTn id="16" dur="500"/>
+                                        <p:tgtEl>
+                                          <p:spTgt spid="102"/>
+                                        </p:tgtEl>
+                                      </p:cBhvr>
+                                    </p:animEffect>
+                                  </p:childTnLst>
+                                </p:cTn>
+                              </p:par>
+                            </p:childTnLst>
+                          </p:cTn>
+                        </p:par>
+                        <p:par>
+                          <p:cTn id="17" fill="hold">
+                            <p:stCondLst>
+                              <p:cond delay="0"/>
+                            </p:stCondLst>
+                            <p:childTnLst>
+                              <p:par>
+                                <p:cTn id="18" presetID="10" presetClass="entr" presetSubtype="0" fill="hold" grpId="3" nodeType="withEffect">
+                                  <p:stCondLst>
+                                    <p:cond delay="0"/>
+                                  </p:stCondLst>
+                                  <p:childTnLst>
+                                    <p:set>
+                                      <p:cBhvr>
+                                        <p:cTn id="19" dur="1" fill="hold">
+                                          <p:stCondLst>
+                                            <p:cond delay="0"/>
+                                          </p:stCondLst>
+                                        </p:cTn>
+                                        <p:tgtEl>
+                                          <p:spTgt spid="103"/>
+                                        </p:tgtEl>
+                                        <p:attrNameLst>
+                                          <p:attrName>style.visibility</p:attrName>
+                                        </p:attrNameLst>
+                                      </p:cBhvr>
+                                      <p:to>
+                                        <p:strVal val="visible"/>
+                                      </p:to>
+                                    </p:set>
+                                    <p:animEffect transition="in" filter="fade">
+                                      <p:cBhvr>
+                                        <p:cTn id="20" dur="500"/>
+                                        <p:tgtEl>
+                                          <p:spTgt spid="103"/>
+                                        </p:tgtEl>
+                                      </p:cBhvr>
+                                    </p:animEffect>
+                                  </p:childTnLst>
+                                </p:cTn>
+                              </p:par>
+                            </p:childTnLst>
+                          </p:cTn>
+                        </p:par>
+                      </p:childTnLst>
+                    </p:cTn>
+                  </p:par>
                   <p:par>
                     <p:cTn id="3" fill="hold">
                       <p:stCondLst>
@@ -21734,103 +22726,6 @@
                                         <p:cTn id="11" dur="500"/>
                                         <p:tgtEl>
                                           <p:spTgt spid="101"/>
-                                        </p:tgtEl>
-                                      </p:cBhvr>
-                                    </p:animEffect>
-                                  </p:childTnLst>
-                                </p:cTn>
-                              </p:par>
-                            </p:childTnLst>
-                          </p:cTn>
-                        </p:par>
-                      </p:childTnLst>
-                    </p:cTn>
-                  </p:par>
-                  <p:par>
-                    <p:cTn id="12" fill="hold">
-                      <p:stCondLst>
-                        <p:cond delay="indefinite"/>
-                      </p:stCondLst>
-                      <p:childTnLst>
-                        <p:par>
-                          <p:cTn id="13" fill="hold">
-                            <p:stCondLst>
-                              <p:cond delay="0"/>
-                            </p:stCondLst>
-                            <p:childTnLst>
-                              <p:par>
-                                <p:cTn id="14" presetID="10" presetClass="entr" presetSubtype="0" fill="hold" grpId="2" nodeType="clickEffect">
-                                  <p:stCondLst>
-                                    <p:cond delay="0"/>
-                                  </p:stCondLst>
-                                  <p:childTnLst>
-                                    <p:set>
-                                      <p:cBhvr>
-                                        <p:cTn id="15" dur="1" fill="hold">
-                                          <p:stCondLst>
-                                            <p:cond delay="0"/>
-                                          </p:stCondLst>
-                                        </p:cTn>
-                                        <p:tgtEl>
-                                          <p:spTgt spid="102"/>
-                                        </p:tgtEl>
-                                        <p:attrNameLst>
-                                          <p:attrName>style.visibility</p:attrName>
-                                        </p:attrNameLst>
-                                      </p:cBhvr>
-                                      <p:to>
-                                        <p:strVal val="visible"/>
-                                      </p:to>
-                                    </p:set>
-                                    <p:animEffect transition="in" filter="fade">
-                                      <p:cBhvr>
-                                        <p:cTn id="16" dur="500"/>
-                                        <p:tgtEl>
-                                          <p:spTgt spid="102"/>
-                                        </p:tgtEl>
-                                      </p:cBhvr>
-                                    </p:animEffect>
-                                  </p:childTnLst>
-                                </p:cTn>
-                              </p:par>
-                            </p:childTnLst>
-                          </p:cTn>
-                        </p:par>
-                        <p:par>
-                          <p:cTn id="17" fill="hold">
-                            <p:stCondLst>
-                              <p:cond delay="0"/>
-                            </p:stCondLst>
-                            <p:childTnLst>
-                              <p:par>
-                                <p:cTn id="18" presetID="10" presetClass="entr" presetSubtype="0" fill="hold" grpId="3" nodeType="withEffect">
-                                  <p:stCondLst>
-                                    <p:cond delay="0"/>
-                                  </p:stCondLst>
-                                  <p:childTnLst>
-                                    <p:set>
-                                      <p:cBhvr>
-                                        <p:cTn id="19" dur="1" fill="hold">
-                                          <p:stCondLst>
-                                            <p:cond delay="0"/>
-                                          </p:stCondLst>
-                                        </p:cTn>
-                                        <p:tgtEl>
-                                          <p:spTgt spid="103"/>
-                                        </p:tgtEl>
-                                        <p:attrNameLst>
-                                          <p:attrName>style.visibility</p:attrName>
-                                        </p:attrNameLst>
-                                      </p:cBhvr>
-                                      <p:to>
-                                        <p:strVal val="visible"/>
-                                      </p:to>
-                                    </p:set>
-                                    <p:animEffect transition="in" filter="fade">
-                                      <p:cBhvr>
-                                        <p:cTn id="20" dur="500"/>
-                                        <p:tgtEl>
-                                          <p:spTgt spid="103"/>
                                         </p:tgtEl>
                                       </p:cBhvr>
                                     </p:animEffect>
@@ -22382,7 +23277,16 @@
                   <a:srgbClr val="000000"/>
                 </a:solidFill>
               </a:rPr>
-              <a:t>generateAdvice(summary, modelVersion) → Advice</a:t>
+              <a:t>generateAdvice(summary, modelVersion)</a:t>
+            </a:r>
+            <a:br/>
+            <a:r>
+              <a:rPr lang="en-US" sz="1400" b="0" i="0" dirty="0">
+                <a:solidFill>
+                  <a:srgbClr val="000000"/>
+                </a:solidFill>
+              </a:rPr>
+              <a:t>→ Advice</a:t>
             </a:r>
           </a:p>
         </p:txBody>
@@ -23302,7 +24206,16 @@
                   <a:srgbClr val="000000"/>
                 </a:solidFill>
               </a:rPr>
-              <a:t>internal parts / responsibilities  ·  key interactions / state  ·  one purposeful model  ·  expected consequence / tradeoff</a:t>
+              <a:t>internal parts / responsibilities  ·  key interactions / state</a:t>
+            </a:r>
+            <a:br/>
+            <a:r>
+              <a:rPr lang="en-US" sz="1400" b="0" i="0" dirty="0">
+                <a:solidFill>
+                  <a:srgbClr val="000000"/>
+                </a:solidFill>
+              </a:rPr>
+              <a:t>one purposeful model  ·  expected consequence / tradeoff</a:t>
             </a:r>
           </a:p>
         </p:txBody>
@@ -25523,18 +26436,18 @@
           <p:nvPr/>
         </p:nvCxnSpPr>
         <p:spPr>
-          <a:xfrm flipV="1">
-            <a:off x="6422000" y="2000000"/>
-            <a:ext cx="0" cy="1980000"/>
-          </a:xfrm>
-          <a:prstGeom prst="straightConnector1">
+          <a:xfrm>
+            <a:off x="6372000" y="1360000"/>
+            <a:ext cx="228000" cy="2620000"/>
+          </a:xfrm>
+          <a:prstGeom prst="bentConnector2">
             <a:avLst/>
           </a:prstGeom>
           <a:ln w="25400">
             <a:solidFill>
               <a:srgbClr val="8E6F3E"/>
             </a:solidFill>
-            <a:tailEnd type="triangle" w="med" len="med"/>
+            <a:headEnd type="triangle" w="med" len="med"/>
           </a:ln>
         </p:spPr>
       </p:cxnSp>
@@ -25887,22 +26800,6 @@
                 </a:solidFill>
               </a:rPr>
               <a:t>?   ?   ?</a:t>
-            </a:r>
-          </a:p>
-          <a:p>
-            <a:pPr algn="ctr">
-              <a:spcBef>
-                <a:spcPts val="140"/>
-              </a:spcBef>
-              <a:buNone/>
-            </a:pPr>
-            <a:r>
-              <a:rPr lang="en-US" sz="1800" b="0" i="0" dirty="0">
-                <a:solidFill>
-                  <a:srgbClr val="555960"/>
-                </a:solidFill>
-              </a:rPr>
-              <a:t>\  |  /</a:t>
             </a:r>
           </a:p>
           <a:p>
@@ -26380,7 +27277,7 @@
 </file>
 
 <file path=ppt/slides/slide5.xml><?xml version="1.0" encoding="utf-8"?>
-<p:sld xmlns:a="http://schemas.openxmlformats.org/drawingml/2006/main" xmlns:r="http://schemas.openxmlformats.org/officeDocument/2006/relationships" xmlns:p="http://schemas.openxmlformats.org/presentationml/2006/main">
+<p:sld xmlns:a="http://schemas.openxmlformats.org/drawingml/2006/main" xmlns:p="http://schemas.openxmlformats.org/presentationml/2006/main">
   <p:cSld>
     <p:spTree>
       <p:nvGrpSpPr>
@@ -27702,6 +28599,50 @@
                             </p:childTnLst>
                           </p:cTn>
                         </p:par>
+                        <p:par>
+                          <p:cTn id="59" fill="hold">
+                            <p:stCondLst>
+                              <p:cond delay="0"/>
+                            </p:stCondLst>
+                            <p:childTnLst>
+                              <p:par>
+                                <p:cTn id="60" presetID="10" presetClass="entr" presetSubtype="0" fill="hold" grpId="13" nodeType="withEffect">
+                                  <p:stCondLst>
+                                    <p:cond delay="0"/>
+                                  </p:stCondLst>
+                                  <p:childTnLst>
+                                    <p:set>
+                                      <p:cBhvr>
+                                        <p:cTn id="61" dur="1" fill="hold">
+                                          <p:stCondLst>
+                                            <p:cond delay="0"/>
+                                          </p:stCondLst>
+                                        </p:cTn>
+                                        <p:tgtEl>
+                                          <p:spTgt spid="113"/>
+                                        </p:tgtEl>
+                                        <p:attrNameLst>
+                                          <p:attrName>style.visibility</p:attrName>
+                                        </p:attrNameLst>
+                                      </p:cBhvr>
+                                      <p:to>
+                                        <p:strVal val="visible"/>
+                                      </p:to>
+                                    </p:set>
+                                    <p:animEffect transition="in" filter="fade">
+                                      <p:cBhvr>
+                                        <p:cTn id="62" dur="500"/>
+                                        <p:tgtEl>
+                                          <p:spTgt spid="113"/>
+                                        </p:tgtEl>
+                                      </p:cBhvr>
+                                    </p:animEffect>
+                                  </p:childTnLst>
+                                </p:cTn>
+                              </p:par>
+                            </p:childTnLst>
+                          </p:cTn>
+                        </p:par>
                       </p:childTnLst>
                     </p:cTn>
                   </p:par>
@@ -27740,6 +28681,7 @@
       <p:bldP spid="111" grpId="10"/>
       <p:bldP spid="112" grpId="11"/>
       <p:bldP spid="109" grpId="12"/>
+      <p:bldP spid="113" grpId="13"/>
     </p:bldLst>
   </p:timing>
 </p:sld>
@@ -28105,7 +29047,7 @@
 </file>
 
 <file path=ppt/slides/slide7.xml><?xml version="1.0" encoding="utf-8"?>
-<p:sld xmlns:a="http://schemas.openxmlformats.org/drawingml/2006/main" xmlns:r="http://schemas.openxmlformats.org/officeDocument/2006/relationships" xmlns:p="http://schemas.openxmlformats.org/presentationml/2006/main">
+<p:sld xmlns:a="http://schemas.openxmlformats.org/drawingml/2006/main" xmlns:p="http://schemas.openxmlformats.org/presentationml/2006/main">
   <p:cSld>
     <p:spTree>
       <p:nvGrpSpPr>
@@ -28887,6 +29829,50 @@
                             </p:childTnLst>
                           </p:cTn>
                         </p:par>
+                        <p:par>
+                          <p:cTn id="30" fill="hold">
+                            <p:stCondLst>
+                              <p:cond delay="0"/>
+                            </p:stCondLst>
+                            <p:childTnLst>
+                              <p:par>
+                                <p:cTn id="31" presetID="10" presetClass="entr" presetSubtype="0" fill="hold" grpId="6" nodeType="withEffect">
+                                  <p:stCondLst>
+                                    <p:cond delay="0"/>
+                                  </p:stCondLst>
+                                  <p:childTnLst>
+                                    <p:set>
+                                      <p:cBhvr>
+                                        <p:cTn id="32" dur="1" fill="hold">
+                                          <p:stCondLst>
+                                            <p:cond delay="0"/>
+                                          </p:stCondLst>
+                                        </p:cTn>
+                                        <p:tgtEl>
+                                          <p:spTgt spid="106"/>
+                                        </p:tgtEl>
+                                        <p:attrNameLst>
+                                          <p:attrName>style.visibility</p:attrName>
+                                        </p:attrNameLst>
+                                      </p:cBhvr>
+                                      <p:to>
+                                        <p:strVal val="visible"/>
+                                      </p:to>
+                                    </p:set>
+                                    <p:animEffect transition="in" filter="fade">
+                                      <p:cBhvr>
+                                        <p:cTn id="33" dur="500"/>
+                                        <p:tgtEl>
+                                          <p:spTgt spid="106"/>
+                                        </p:tgtEl>
+                                      </p:cBhvr>
+                                    </p:animEffect>
+                                  </p:childTnLst>
+                                </p:cTn>
+                              </p:par>
+                            </p:childTnLst>
+                          </p:cTn>
+                        </p:par>
                       </p:childTnLst>
                     </p:cTn>
                   </p:par>
@@ -28918,6 +29904,7 @@
       <p:bldP spid="103" grpId="3"/>
       <p:bldP spid="104" grpId="4"/>
       <p:bldP spid="105" grpId="5"/>
+      <p:bldP spid="106" grpId="6"/>
     </p:bldLst>
   </p:timing>
 </p:sld>

</xml_diff>

<commit_message>
course(design): copyedit pass 2 — title punctuation, notes crib/===== structure, diagram-label legibility, spacing
Rubric fixes (self-communicate/mage-presenting-style):
- S8 + S36 titles: drop trailing period on two-sentence titles (house rule;
  matches 1-6-Architecture precedent)
- All 36 notes: normalize to house form — time+italic purpose line, presenter
  crib bullets, ===== delimiter, transcript below with ANIMATE preserved;
  author-facing des.md residue repurposed as presenter crib
- Diagram typography: bump sub-floor labels (S2 open/terminal, S11 state +
  entry/exit + retry, S12 lifetime bars + note, S23 wall caption) with box
  widening where needed
- S14: open the gap between budget strip and question box

Verified: pptx_validate 0 OPC + 0 schema; 36 slides; 0 dangling animation
targets; ANIMATE count/order matches click builds; LibreOffice round-trip
re-rendered and inspected.

Co-Authored-By: Claude Opus 4.8 <noreply@anthropic.com>
</commit_message>
<xml_diff>
--- a/course/lectures/act-1-foundations/07-design/1-7-Design.pptx
+++ b/course/lectures/act-1-foundations/07-design/1-7-Design.pptx
@@ -501,7 +501,7 @@
 </file>
 
 <file path=ppt/notesSlides/notesSlide1.xml><?xml version="1.0" encoding="utf-8"?>
-<p:notes xmlns:a="http://schemas.openxmlformats.org/drawingml/2006/main" xmlns:r="http://schemas.openxmlformats.org/officeDocument/2006/relationships" xmlns:p="http://schemas.openxmlformats.org/presentationml/2006/main">
+<p:notes xmlns:a="http://schemas.openxmlformats.org/drawingml/2006/main" xmlns:p="http://schemas.openxmlformats.org/presentationml/2006/main">
   <p:cSld>
     <p:spTree>
       <p:nvGrpSpPr>
@@ -547,7 +547,13 @@
           <a:p>
             <a:r>
               <a:rPr dirty="0"/>
-              <a:t>Last time we chose how one acceptable system should be organized. We ended with major parts, boundaries, responsibilities, interfaces, and rules governing interaction.</a:t>
+              <a:t xml:space="preserve">- Callback: the closing Architecture slide — parts, responsibilities, interfaces.</a:t>
+            </a:r>
+          </a:p>
+          <a:p>
+            <a:r>
+              <a:rPr dirty="0"/>
+              <a:t xml:space="preserve">- Land the question: we know WHAT each part must do, not yet HOW.</a:t>
             </a:r>
           </a:p>
           <a:p>
@@ -556,7 +562,7 @@
           <a:p>
             <a:r>
               <a:rPr dirty="0"/>
-              <a:t>But look at one of those parts. We know what responsibility it has. We know how the rest of the system is allowed to interact with it. We still have not said how it actually does its job.</a:t>
+              <a:t xml:space="preserve">=====</a:t>
             </a:r>
           </a:p>
           <a:p>
@@ -565,7 +571,7 @@
           <a:p>
             <a:r>
               <a:rPr dirty="0"/>
-              <a:t>That is today's engineering problem. Given one of the parts produced by Architecture, how should we engineer its internals so that it realizes the responsibility we assigned to it?</a:t>
+              <a:t xml:space="preserve">Last time we chose how one acceptable system should be organized. We ended with major parts, boundaries, responsibilities, interfaces, and rules governing interaction.</a:t>
             </a:r>
           </a:p>
           <a:p>
@@ -574,7 +580,25 @@
           <a:p>
             <a:r>
               <a:rPr dirty="0"/>
-              <a:t>That is Design.</a:t>
+              <a:t xml:space="preserve">But look at one of those parts. We know what responsibility it has. We know how the rest of the system is allowed to interact with it. We still have not said how it actually does its job.</a:t>
+            </a:r>
+          </a:p>
+          <a:p>
+            <a:endParaRPr dirty="0"/>
+          </a:p>
+          <a:p>
+            <a:r>
+              <a:rPr dirty="0"/>
+              <a:t xml:space="preserve">That is today's engineering problem. Given one of the parts produced by Architecture, how should we engineer its internals so that it realizes the responsibility we assigned to it?</a:t>
+            </a:r>
+          </a:p>
+          <a:p>
+            <a:endParaRPr dirty="0"/>
+          </a:p>
+          <a:p>
+            <a:r>
+              <a:rPr dirty="0"/>
+              <a:t xml:space="preserve">That is Design.</a:t>
             </a:r>
           </a:p>
         </p:txBody>
@@ -588,7 +612,7 @@
 </file>
 
 <file path=ppt/notesSlides/notesSlide10.xml><?xml version="1.0" encoding="utf-8"?>
-<p:notes xmlns:a="http://schemas.openxmlformats.org/drawingml/2006/main" xmlns:r="http://schemas.openxmlformats.org/officeDocument/2006/relationships" xmlns:p="http://schemas.openxmlformats.org/presentationml/2006/main">
+<p:notes xmlns:a="http://schemas.openxmlformats.org/drawingml/2006/main" xmlns:p="http://schemas.openxmlformats.org/presentationml/2006/main">
   <p:cSld>
     <p:spTree>
       <p:nvGrpSpPr>
@@ -634,16 +658,7 @@
           <a:p>
             <a:r>
               <a:rPr dirty="0"/>
-              <a:t>Section divider and callback. Specification and Architecture already taught purposeful modeling; Design uses the same discipline at a finer scope.</a:t>
-            </a:r>
-          </a:p>
-          <a:p>
-            <a:endParaRPr dirty="0"/>
-          </a:p>
-          <a:p>
-            <a:r>
-              <a:rPr dirty="0"/>
-              <a:t>Explicitly call back to Specification and Architecture. Do not re-teach the MAGE model taxonomy.</a:t>
+              <a:t xml:space="preserve">- Call back to Specification and Architecture; do not re-teach the MAGE model taxonomy.</a:t>
             </a:r>
           </a:p>
         </p:txBody>
@@ -657,7 +672,7 @@
 </file>
 
 <file path=ppt/notesSlides/notesSlide11.xml><?xml version="1.0" encoding="utf-8"?>
-<p:notes xmlns:a="http://schemas.openxmlformats.org/drawingml/2006/main" xmlns:r="http://schemas.openxmlformats.org/officeDocument/2006/relationships" xmlns:p="http://schemas.openxmlformats.org/presentationml/2006/main">
+<p:notes xmlns:a="http://schemas.openxmlformats.org/drawingml/2006/main" xmlns:p="http://schemas.openxmlformats.org/presentationml/2006/main">
   <p:cSld>
     <p:spTree>
       <p:nvGrpSpPr>
@@ -703,25 +718,13 @@
           <a:p>
             <a:r>
               <a:rPr dirty="0"/>
-              <a:t>Behavioral model. Use a concrete component and a small state/transition model to answer a real internal question.</a:t>
-            </a:r>
-          </a:p>
-          <a:p>
-            <a:endParaRPr dirty="0"/>
+              <a:t xml:space="preserve">- Behavioral model of one concrete component; make the property–model connection explicit.</a:t>
+            </a:r>
           </a:p>
           <a:p>
             <a:r>
               <a:rPr dirty="0"/>
-              <a:t>Question: Can a request return advice before validation completes? Make the property/model connection explicit.</a:t>
-            </a:r>
-          </a:p>
-          <a:p>
-            <a:endParaRPr dirty="0"/>
-          </a:p>
-          <a:p>
-            <a:r>
-              <a:rPr dirty="0"/>
-              <a:t>Behavioral question → behavioral model.</a:t>
+              <a:t xml:space="preserve">- Question: can a request return advice before validation completes?</a:t>
             </a:r>
           </a:p>
         </p:txBody>
@@ -735,7 +738,7 @@
 </file>
 
 <file path=ppt/notesSlides/notesSlide12.xml><?xml version="1.0" encoding="utf-8"?>
-<p:notes xmlns:a="http://schemas.openxmlformats.org/drawingml/2006/main" xmlns:r="http://schemas.openxmlformats.org/officeDocument/2006/relationships" xmlns:p="http://schemas.openxmlformats.org/presentationml/2006/main">
+<p:notes xmlns:a="http://schemas.openxmlformats.org/drawingml/2006/main" xmlns:p="http://schemas.openxmlformats.org/presentationml/2006/main">
   <p:cSld>
     <p:spTree>
       <p:nvGrpSpPr>
@@ -781,25 +784,13 @@
           <a:p>
             <a:r>
               <a:rPr dirty="0"/>
-              <a:t>Ownership model. Show that lifecycle, concurrency, cleanup, and failure questions require a different reduction of the same component.</a:t>
-            </a:r>
-          </a:p>
-          <a:p>
-            <a:endParaRPr dirty="0"/>
+              <a:t xml:space="preserve">- Same component, different reduction: ownership and lifetimes.</a:t>
+            </a:r>
           </a:p>
           <a:p>
             <a:r>
               <a:rPr dirty="0"/>
-              <a:t>Same Advice Generator, but show request/context/model-result ownership and lifetimes.</a:t>
-            </a:r>
-          </a:p>
-          <a:p>
-            <a:endParaRPr dirty="0"/>
-          </a:p>
-          <a:p>
-            <a:r>
-              <a:rPr dirty="0"/>
-              <a:t>Question: Can two requests mutate the same working state? Ownership question → ownership model.</a:t>
+              <a:t xml:space="preserve">- Question: can two requests mutate the same working state?</a:t>
             </a:r>
           </a:p>
         </p:txBody>
@@ -813,7 +804,7 @@
 </file>
 
 <file path=ppt/notesSlides/notesSlide13.xml><?xml version="1.0" encoding="utf-8"?>
-<p:notes xmlns:a="http://schemas.openxmlformats.org/drawingml/2006/main" xmlns:r="http://schemas.openxmlformats.org/officeDocument/2006/relationships" xmlns:p="http://schemas.openxmlformats.org/presentationml/2006/main">
+<p:notes xmlns:a="http://schemas.openxmlformats.org/drawingml/2006/main" xmlns:p="http://schemas.openxmlformats.org/presentationml/2006/main">
   <p:cSld>
     <p:spTree>
       <p:nvGrpSpPr>
@@ -859,25 +850,13 @@
           <a:p>
             <a:r>
               <a:rPr dirty="0"/>
-              <a:t>Structural model. Make change locality and internal coupling analyzable.</a:t>
-            </a:r>
-          </a:p>
-          <a:p>
-            <a:endParaRPr dirty="0"/>
+              <a:t xml:space="preserve">- Structural model: change locality and internal coupling.</a:t>
+            </a:r>
           </a:p>
           <a:p>
             <a:r>
               <a:rPr dirty="0"/>
-              <a:t>Same component decomposed into internal collaborators.</a:t>
-            </a:r>
-          </a:p>
-          <a:p>
-            <a:endParaRPr dirty="0"/>
-          </a:p>
-          <a:p>
-            <a:r>
-              <a:rPr dirty="0"/>
-              <a:t>Question: Can we replace the advice model without changing validation? Change question → structural model.</a:t>
+              <a:t xml:space="preserve">- Question: can we replace the advice model without changing validation?</a:t>
             </a:r>
           </a:p>
         </p:txBody>
@@ -891,7 +870,7 @@
 </file>
 
 <file path=ppt/notesSlides/notesSlide14.xml><?xml version="1.0" encoding="utf-8"?>
-<p:notes xmlns:a="http://schemas.openxmlformats.org/drawingml/2006/main" xmlns:r="http://schemas.openxmlformats.org/officeDocument/2006/relationships" xmlns:p="http://schemas.openxmlformats.org/presentationml/2006/main">
+<p:notes xmlns:a="http://schemas.openxmlformats.org/drawingml/2006/main" xmlns:p="http://schemas.openxmlformats.org/presentationml/2006/main">
   <p:cSld>
     <p:spTree>
       <p:nvGrpSpPr>
@@ -937,34 +916,19 @@
           <a:p>
             <a:r>
               <a:rPr dirty="0"/>
-              <a:t>Measurement model. Make one resource/performance bound explicit rather than hand-waving “efficient.”</a:t>
-            </a:r>
-          </a:p>
-          <a:p>
-            <a:endParaRPr dirty="0"/>
+              <a:t xml:space="preserve">- Measurement model: make one bound explicit instead of hand-waving “efficient”.</a:t>
+            </a:r>
           </a:p>
           <a:p>
             <a:r>
               <a:rPr dirty="0"/>
-              <a:t>Same internals with latency/memory bounds.</a:t>
-            </a:r>
-          </a:p>
-          <a:p>
-            <a:endParaRPr dirty="0"/>
+              <a:t xml:space="preserve">- Question: can the component meet its 2-second budget?</a:t>
+            </a:r>
           </a:p>
           <a:p>
             <a:r>
               <a:rPr dirty="0"/>
-              <a:t>Question: Can the component meet its 2-second budget? Quantitative question → measurement model.</a:t>
-            </a:r>
-          </a:p>
-          <a:p>
-            <a:endParaRPr dirty="0"/>
-          </a:p>
-          <a:p>
-            <a:r>
-              <a:rPr dirty="0"/>
-              <a:t>Do not try to cover all six MAGE model classes. Four is already plenty.</a:t>
+              <a:t xml:space="preserve">- Do not cover all six MAGE model classes; four is plenty.</a:t>
             </a:r>
           </a:p>
         </p:txBody>
@@ -978,7 +942,7 @@
 </file>
 
 <file path=ppt/notesSlides/notesSlide15.xml><?xml version="1.0" encoding="utf-8"?>
-<p:notes xmlns:a="http://schemas.openxmlformats.org/drawingml/2006/main" xmlns:r="http://schemas.openxmlformats.org/officeDocument/2006/relationships" xmlns:p="http://schemas.openxmlformats.org/presentationml/2006/main">
+<p:notes xmlns:a="http://schemas.openxmlformats.org/drawingml/2006/main" xmlns:p="http://schemas.openxmlformats.org/presentationml/2006/main">
   <p:cSld>
     <p:spTree>
       <p:nvGrpSpPr>
@@ -1024,7 +988,13 @@
           <a:p>
             <a:r>
               <a:rPr dirty="0"/>
-              <a:t>Same component. Four representations.</a:t>
+              <a:t xml:space="preserve">- Same component, four representations; none of them is “the Design”.</a:t>
+            </a:r>
+          </a:p>
+          <a:p>
+            <a:r>
+              <a:rPr dirty="0"/>
+              <a:t xml:space="preserve">- Scope and purpose, not representation, make something Architecture or Design.</a:t>
             </a:r>
           </a:p>
           <a:p>
@@ -1033,7 +1003,7 @@
           <a:p>
             <a:r>
               <a:rPr dirty="0"/>
-              <a:t>None is “the Design.”</a:t>
+              <a:t xml:space="preserve">=====</a:t>
             </a:r>
           </a:p>
           <a:p>
@@ -1042,7 +1012,7 @@
           <a:p>
             <a:r>
               <a:rPr dirty="0"/>
-              <a:t>We deliberately threw information away differently each time because different information was relevant to each engineering question.</a:t>
+              <a:t xml:space="preserve">Same component. Four representations.</a:t>
             </a:r>
           </a:p>
           <a:p>
@@ -1051,7 +1021,25 @@
           <a:p>
             <a:r>
               <a:rPr dirty="0"/>
-              <a:t>The representation is not what makes something Architecture or Design. Scope and purpose do.</a:t>
+              <a:t xml:space="preserve">None is “the Design.”</a:t>
+            </a:r>
+          </a:p>
+          <a:p>
+            <a:endParaRPr dirty="0"/>
+          </a:p>
+          <a:p>
+            <a:r>
+              <a:rPr dirty="0"/>
+              <a:t xml:space="preserve">We deliberately threw information away differently each time because different information was relevant to each engineering question.</a:t>
+            </a:r>
+          </a:p>
+          <a:p>
+            <a:endParaRPr dirty="0"/>
+          </a:p>
+          <a:p>
+            <a:r>
+              <a:rPr dirty="0"/>
+              <a:t xml:space="preserve">The representation is not what makes something Architecture or Design. Scope and purpose do.</a:t>
             </a:r>
           </a:p>
         </p:txBody>
@@ -1065,7 +1053,7 @@
 </file>
 
 <file path=ppt/notesSlides/notesSlide16.xml><?xml version="1.0" encoding="utf-8"?>
-<p:notes xmlns:a="http://schemas.openxmlformats.org/drawingml/2006/main" xmlns:r="http://schemas.openxmlformats.org/officeDocument/2006/relationships" xmlns:p="http://schemas.openxmlformats.org/presentationml/2006/main">
+<p:notes xmlns:a="http://schemas.openxmlformats.org/drawingml/2006/main" xmlns:p="http://schemas.openxmlformats.org/presentationml/2006/main">
   <p:cSld>
     <p:spTree>
       <p:nvGrpSpPr>
@@ -1111,16 +1099,7 @@
           <a:p>
             <a:r>
               <a:rPr dirty="0"/>
-              <a:t>Section divider. We are not introducing “best practices”; we are identifying recurring engineering questions with alternative answers and consequences.</a:t>
-            </a:r>
-          </a:p>
-          <a:p>
-            <a:endParaRPr dirty="0"/>
-          </a:p>
-          <a:p>
-            <a:r>
-              <a:rPr dirty="0"/>
-              <a:t>No catalogue of named patterns.</a:t>
+              <a:t xml:space="preserve">- Recurring questions with alternatives and consequences — not “best practices”, no catalogue of named patterns.</a:t>
             </a:r>
           </a:p>
         </p:txBody>
@@ -1134,7 +1113,7 @@
 </file>
 
 <file path=ppt/notesSlides/notesSlide17.xml><?xml version="1.0" encoding="utf-8"?>
-<p:notes xmlns:a="http://schemas.openxmlformats.org/drawingml/2006/main" xmlns:r="http://schemas.openxmlformats.org/officeDocument/2006/relationships" xmlns:p="http://schemas.openxmlformats.org/presentationml/2006/main">
+<p:notes xmlns:a="http://schemas.openxmlformats.org/drawingml/2006/main" xmlns:p="http://schemas.openxmlformats.org/presentationml/2006/main">
   <p:cSld>
     <p:spTree>
       <p:nvGrpSpPr>
@@ -1180,34 +1159,19 @@
           <a:p>
             <a:r>
               <a:rPr dirty="0"/>
-              <a:t>Authority. When representations disagree, which one wins?</a:t>
-            </a:r>
-          </a:p>
-          <a:p>
-            <a:endParaRPr dirty="0"/>
+              <a:t xml:space="preserve">- Distinguish authoritative, derived, cached, replicated state.</a:t>
+            </a:r>
           </a:p>
           <a:p>
             <a:r>
               <a:rPr dirty="0"/>
-              <a:t>Distinguish canonical (authoritative) state from cached, replicated, and derived representations.</a:t>
-            </a:r>
-          </a:p>
-          <a:p>
-            <a:endParaRPr dirty="0"/>
+              <a:t xml:space="preserve">- When representations disagree, which one wins?</a:t>
+            </a:r>
           </a:p>
           <a:p>
             <a:r>
               <a:rPr dirty="0"/>
-              <a:t>Key distinctions: authoritative · derived · cached · replicated.</a:t>
-            </a:r>
-          </a:p>
-          <a:p>
-            <a:endParaRPr dirty="0"/>
-          </a:p>
-          <a:p>
-            <a:r>
-              <a:rPr dirty="0"/>
-              <a:t>Do not drift into consistency yet.</a:t>
+              <a:t xml:space="preserve">- Do not drift into consistency yet.</a:t>
             </a:r>
           </a:p>
         </p:txBody>
@@ -1221,7 +1185,7 @@
 </file>
 
 <file path=ppt/notesSlides/notesSlide18.xml><?xml version="1.0" encoding="utf-8"?>
-<p:notes xmlns:a="http://schemas.openxmlformats.org/drawingml/2006/main" xmlns:r="http://schemas.openxmlformats.org/officeDocument/2006/relationships" xmlns:p="http://schemas.openxmlformats.org/presentationml/2006/main">
+<p:notes xmlns:a="http://schemas.openxmlformats.org/drawingml/2006/main" xmlns:p="http://schemas.openxmlformats.org/presentationml/2006/main">
   <p:cSld>
     <p:spTree>
       <p:nvGrpSpPr>
@@ -1267,34 +1231,19 @@
           <a:p>
             <a:r>
               <a:rPr dirty="0"/>
-              <a:t>Once state exists in multiple places, ask what clients must actually observe.</a:t>
-            </a:r>
-          </a:p>
-          <a:p>
-            <a:endParaRPr dirty="0"/>
+              <a:t xml:space="preserve">- Contrast the two required semantics; replication topology does not determine consistency.</a:t>
+            </a:r>
           </a:p>
           <a:p>
             <a:r>
               <a:rPr dirty="0"/>
-              <a:t>Option A: readers must observe the latest completed write. Option B: readers may temporarily observe an older value. Then work the consequences under concurrency and failure.</a:t>
-            </a:r>
-          </a:p>
-          <a:p>
-            <a:endParaRPr dirty="0"/>
+              <a:t xml:space="preserve">- Work the consequences under concurrency and failure.</a:t>
+            </a:r>
           </a:p>
           <a:p>
             <a:r>
               <a:rPr dirty="0"/>
-              <a:t>Use two contrasting required semantics, not “central vs replicated.” Replication does not determine consistency — requirements do.</a:t>
-            </a:r>
-          </a:p>
-          <a:p>
-            <a:endParaRPr dirty="0"/>
-          </a:p>
-          <a:p>
-            <a:r>
-              <a:rPr dirty="0"/>
-              <a:t>If CAP appears, it should be subordinate and technically correct, not the organizing concept.</a:t>
+              <a:t xml:space="preserve">- If CAP comes up, keep it subordinate and technically correct.</a:t>
             </a:r>
           </a:p>
         </p:txBody>
@@ -1308,7 +1257,7 @@
 </file>
 
 <file path=ppt/notesSlides/notesSlide19.xml><?xml version="1.0" encoding="utf-8"?>
-<p:notes xmlns:a="http://schemas.openxmlformats.org/drawingml/2006/main" xmlns:r="http://schemas.openxmlformats.org/officeDocument/2006/relationships" xmlns:p="http://schemas.openxmlformats.org/presentationml/2006/main">
+<p:notes xmlns:a="http://schemas.openxmlformats.org/drawingml/2006/main" xmlns:p="http://schemas.openxmlformats.org/presentationml/2006/main">
   <p:cSld>
     <p:spTree>
       <p:nvGrpSpPr>
@@ -1354,25 +1303,13 @@
           <a:p>
             <a:r>
               <a:rPr dirty="0"/>
-              <a:t>Immediate versus deferred work. Expose the consequences for latency, ordering, failure handling, retries, and idempotence.</a:t>
-            </a:r>
-          </a:p>
-          <a:p>
-            <a:endParaRPr dirty="0"/>
+              <a:t xml:space="preserve">- Tradeoff: immediacy and simple completion vs latency isolation and resilience.</a:t>
+            </a:r>
           </a:p>
           <a:p>
             <a:r>
               <a:rPr dirty="0"/>
-              <a:t>Tradeoff: immediacy and simple completion semantics versus latency isolation and resilience.</a:t>
-            </a:r>
-          </a:p>
-          <a:p>
-            <a:endParaRPr dirty="0"/>
-          </a:p>
-          <a:p>
-            <a:r>
-              <a:rPr dirty="0"/>
-              <a:t>Then note that retries, idempotence, and order become design concerns on the deferred side.</a:t>
+              <a:t xml:space="preserve">- The deferred side takes on retries, idempotence, and ordering.</a:t>
             </a:r>
           </a:p>
         </p:txBody>
@@ -1386,7 +1323,7 @@
 </file>
 
 <file path=ppt/notesSlides/notesSlide2.xml><?xml version="1.0" encoding="utf-8"?>
-<p:notes xmlns:a="http://schemas.openxmlformats.org/drawingml/2006/main" xmlns:r="http://schemas.openxmlformats.org/officeDocument/2006/relationships" xmlns:p="http://schemas.openxmlformats.org/presentationml/2006/main">
+<p:notes xmlns:a="http://schemas.openxmlformats.org/drawingml/2006/main" xmlns:p="http://schemas.openxmlformats.org/presentationml/2006/main">
   <p:cSld>
     <p:spTree>
       <p:nvGrpSpPr>
@@ -1432,7 +1369,19 @@
           <a:p>
             <a:r>
               <a:rPr dirty="0"/>
-              <a:t>There is an immediate problem with saying Design works “inside the box.”</a:t>
+              <a:t xml:space="preserve">- Open one box at a time; keep it slightly playful.</a:t>
+            </a:r>
+          </a:p>
+          <a:p>
+            <a:r>
+              <a:rPr dirty="0"/>
+              <a:t xml:space="preserve">- Do not explain where the dividing lines are yet — that is our first problem today.</a:t>
+            </a:r>
+          </a:p>
+          <a:p>
+            <a:r>
+              <a:rPr dirty="0"/>
+              <a:t xml:space="preserve">- Lands directly on Section 1.</a:t>
             </a:r>
           </a:p>
           <a:p>
@@ -1441,7 +1390,7 @@
           <a:p>
             <a:r>
               <a:rPr dirty="0"/>
-              <a:t>We open the box and discover more boxes.</a:t>
+              <a:t xml:space="preserve">=====</a:t>
             </a:r>
           </a:p>
           <a:p>
@@ -1450,7 +1399,7 @@
           <a:p>
             <a:r>
               <a:rPr dirty="0"/>
-              <a:t>ANIMATE</a:t>
+              <a:t xml:space="preserve">There is an immediate problem with saying Design works “inside the box.”</a:t>
             </a:r>
           </a:p>
           <a:p>
@@ -1459,7 +1408,7 @@
           <a:p>
             <a:r>
               <a:rPr dirty="0"/>
-              <a:t>And sometimes one of those boxes is still substantial enough that we need to organize it before we can sensibly implement it.</a:t>
+              <a:t xml:space="preserve">We open the box and discover more boxes.</a:t>
             </a:r>
           </a:p>
           <a:p>
@@ -1468,7 +1417,7 @@
           <a:p>
             <a:r>
               <a:rPr dirty="0"/>
-              <a:t>ANIMATE</a:t>
+              <a:t xml:space="preserve">ANIMATE</a:t>
             </a:r>
           </a:p>
           <a:p>
@@ -1477,7 +1426,7 @@
           <a:p>
             <a:r>
               <a:rPr dirty="0"/>
-              <a:t>We can keep doing this.</a:t>
+              <a:t xml:space="preserve">And sometimes one of those boxes is still substantial enough that we need to organize it before we can sensibly implement it.</a:t>
             </a:r>
           </a:p>
           <a:p>
@@ -1486,7 +1435,7 @@
           <a:p>
             <a:r>
               <a:rPr dirty="0"/>
-              <a:t>ANIMATE</a:t>
+              <a:t xml:space="preserve">ANIMATE</a:t>
             </a:r>
           </a:p>
           <a:p>
@@ -1495,7 +1444,7 @@
           <a:p>
             <a:r>
               <a:rPr dirty="0"/>
-              <a:t>But not forever. Eventually we reach objects, functions, data structures, algorithms, or small collaborations that we can reason about directly.</a:t>
+              <a:t xml:space="preserve">We can keep doing this.</a:t>
             </a:r>
           </a:p>
           <a:p>
@@ -1504,7 +1453,7 @@
           <a:p>
             <a:r>
               <a:rPr dirty="0"/>
-              <a:t>I am deliberately not going to explain where the dividing lines are yet. That is our first problem today.</a:t>
+              <a:t xml:space="preserve">ANIMATE</a:t>
             </a:r>
           </a:p>
           <a:p>
@@ -1513,7 +1462,16 @@
           <a:p>
             <a:r>
               <a:rPr dirty="0"/>
-              <a:t>Excellent transition into Section 1.</a:t>
+              <a:t xml:space="preserve">But not forever. Eventually we reach objects, functions, data structures, algorithms, or small collaborations that we can reason about directly.</a:t>
+            </a:r>
+          </a:p>
+          <a:p>
+            <a:endParaRPr dirty="0"/>
+          </a:p>
+          <a:p>
+            <a:r>
+              <a:rPr dirty="0"/>
+              <a:t xml:space="preserve">I am deliberately not going to explain where the dividing lines are yet. That is our first problem today.</a:t>
             </a:r>
           </a:p>
         </p:txBody>
@@ -1527,7 +1485,7 @@
 </file>
 
 <file path=ppt/notesSlides/notesSlide20.xml><?xml version="1.0" encoding="utf-8"?>
-<p:notes xmlns:a="http://schemas.openxmlformats.org/drawingml/2006/main" xmlns:r="http://schemas.openxmlformats.org/officeDocument/2006/relationships" xmlns:p="http://schemas.openxmlformats.org/presentationml/2006/main">
+<p:notes xmlns:a="http://schemas.openxmlformats.org/drawingml/2006/main" xmlns:p="http://schemas.openxmlformats.org/presentationml/2006/main">
   <p:cSld>
     <p:spTree>
       <p:nvGrpSpPr>
@@ -1573,34 +1531,13 @@
           <a:p>
             <a:r>
               <a:rPr dirty="0"/>
-              <a:t>Indirection. Fundamental-theorem territory. Direct dependency versus an additional level of indirection; what isolation and substitution buy, and what complexity they cost.</a:t>
-            </a:r>
-          </a:p>
-          <a:p>
-            <a:endParaRPr dirty="0"/>
+              <a:t xml:space="preserve">- Fundamental-theorem territory: what isolation buys, what complexity it costs.</a:t>
+            </a:r>
           </a:p>
           <a:p>
             <a:r>
               <a:rPr dirty="0"/>
-              <a:t>Examples of I: interface, adapter, factory, dependency injection, proxy.</a:t>
-            </a:r>
-          </a:p>
-          <a:p>
-            <a:endParaRPr dirty="0"/>
-          </a:p>
-          <a:p>
-            <a:r>
-              <a:rPr dirty="0"/>
-              <a:t>Question: What future change are we buying isolation from?</a:t>
-            </a:r>
-          </a:p>
-          <a:p>
-            <a:endParaRPr dirty="0"/>
-          </a:p>
-          <a:p>
-            <a:r>
-              <a:rPr dirty="0"/>
-              <a:t>An additional layer is not automatically sophisticated or better. Indirection buys flexibility by spending complexity.</a:t>
+              <a:t xml:space="preserve">- An additional layer is not automatically sophisticated or better.</a:t>
             </a:r>
           </a:p>
         </p:txBody>
@@ -1614,7 +1551,7 @@
 </file>
 
 <file path=ppt/notesSlides/notesSlide21.xml><?xml version="1.0" encoding="utf-8"?>
-<p:notes xmlns:a="http://schemas.openxmlformats.org/drawingml/2006/main" xmlns:r="http://schemas.openxmlformats.org/officeDocument/2006/relationships" xmlns:p="http://schemas.openxmlformats.org/presentationml/2006/main">
+<p:notes xmlns:a="http://schemas.openxmlformats.org/drawingml/2006/main" xmlns:p="http://schemas.openxmlformats.org/presentationml/2006/main">
   <p:cSld>
     <p:spTree>
       <p:nvGrpSpPr>
@@ -1660,34 +1597,13 @@
           <a:p>
             <a:r>
               <a:rPr dirty="0"/>
-              <a:t>This is where Parnas lands.</a:t>
-            </a:r>
-          </a:p>
-          <a:p>
-            <a:endParaRPr dirty="0"/>
+              <a:t xml:space="preserve">- Parnas 1972, information hiding: hide the decisions most likely to change behind stable seams.</a:t>
+            </a:r>
           </a:p>
           <a:p>
             <a:r>
               <a:rPr dirty="0"/>
-              <a:t>Show two internal decompositions of the same responsibility: A, by processing steps; B, around likely-to-change decisions.</a:t>
-            </a:r>
-          </a:p>
-          <a:p>
-            <a:endParaRPr dirty="0"/>
-          </a:p>
-          <a:p>
-            <a:r>
-              <a:rPr dirty="0"/>
-              <a:t>Ask: When X changes, which design contains the change? Use Parnas 1972 and information hiding — hide the decisions most likely to change behind stable seams.</a:t>
-            </a:r>
-          </a:p>
-          <a:p>
-            <a:endParaRPr dirty="0"/>
-          </a:p>
-          <a:p>
-            <a:r>
-              <a:rPr dirty="0"/>
-              <a:t>Modularity briefly recovers decomposability, understandability, continuity / change containment, and protection / failure containment. Do not make the five Meyer criteria into slide bullets.</a:t>
+              <a:t xml:space="preserve">- Recover modularity verbally — decomposability, understandability, change containment, failure containment; do not enumerate the five Meyer criteria.</a:t>
             </a:r>
           </a:p>
         </p:txBody>
@@ -1701,7 +1617,7 @@
 </file>
 
 <file path=ppt/notesSlides/notesSlide22.xml><?xml version="1.0" encoding="utf-8"?>
-<p:notes xmlns:a="http://schemas.openxmlformats.org/drawingml/2006/main" xmlns:r="http://schemas.openxmlformats.org/officeDocument/2006/relationships" xmlns:p="http://schemas.openxmlformats.org/presentationml/2006/main">
+<p:notes xmlns:a="http://schemas.openxmlformats.org/drawingml/2006/main" xmlns:p="http://schemas.openxmlformats.org/presentationml/2006/main">
   <p:cSld>
     <p:spTree>
       <p:nvGrpSpPr>
@@ -1747,25 +1663,13 @@
           <a:p>
             <a:r>
               <a:rPr dirty="0"/>
-              <a:t>Synthesis table. Recurring question → plausible alternatives → property/tradeoff.</a:t>
-            </a:r>
-          </a:p>
-          <a:p>
-            <a:endParaRPr dirty="0"/>
+              <a:t xml:space="preserve">- Recurring question → plausible alternatives → tradeoff; explicitly reject catalogue thinking.</a:t>
+            </a:r>
           </a:p>
           <a:p>
             <a:r>
               <a:rPr dirty="0"/>
-              <a:t>Design is not choosing the “good” side. It is choosing which consequences fit the problem.</a:t>
-            </a:r>
-          </a:p>
-          <a:p>
-            <a:endParaRPr dirty="0"/>
-          </a:p>
-          <a:p>
-            <a:r>
-              <a:rPr dirty="0"/>
-              <a:t>Explicitly reject catalogue thinking.</a:t>
+              <a:t xml:space="preserve">- Design is choosing which consequences fit the problem, not the “good” side.</a:t>
             </a:r>
           </a:p>
         </p:txBody>
@@ -1779,7 +1683,7 @@
 </file>
 
 <file path=ppt/notesSlides/notesSlide23.xml><?xml version="1.0" encoding="utf-8"?>
-<p:notes xmlns:a="http://schemas.openxmlformats.org/drawingml/2006/main" xmlns:r="http://schemas.openxmlformats.org/officeDocument/2006/relationships" xmlns:p="http://schemas.openxmlformats.org/presentationml/2006/main">
+<p:notes xmlns:a="http://schemas.openxmlformats.org/drawingml/2006/main" xmlns:p="http://schemas.openxmlformats.org/presentationml/2006/main">
   <p:cSld>
     <p:spTree>
       <p:nvGrpSpPr>
@@ -1825,7 +1729,13 @@
           <a:p>
             <a:r>
               <a:rPr dirty="0"/>
-              <a:t>Remember this wall from Architecture. At the time, we deliberately did not draw the plumbing.</a:t>
+              <a:t xml:space="preserve">- Payoff of the Architecture wall slide; two builds — the pipe fits, then a bend does not.</a:t>
+            </a:r>
+          </a:p>
+          <a:p>
+            <a:r>
+              <a:rPr dirty="0"/>
+              <a:t xml:space="preserve">- A misfit is information about the strategy, not just a plumbing failure.</a:t>
             </a:r>
           </a:p>
           <a:p>
@@ -1834,7 +1744,7 @@
           <a:p>
             <a:r>
               <a:rPr dirty="0"/>
-              <a:t>Architecture had chosen the wall location, depth, and permitted penetrations. Those choices created a space in which plumbing Design would later occur.</a:t>
+              <a:t xml:space="preserve">=====</a:t>
             </a:r>
           </a:p>
           <a:p>
@@ -1843,7 +1753,7 @@
           <a:p>
             <a:r>
               <a:rPr dirty="0"/>
-              <a:t>Now we are the plumbing designer.</a:t>
+              <a:t xml:space="preserve">Remember this wall from Architecture. At the time, we deliberately did not draw the plumbing.</a:t>
             </a:r>
           </a:p>
           <a:p>
@@ -1852,7 +1762,7 @@
           <a:p>
             <a:r>
               <a:rPr dirty="0"/>
-              <a:t>ANIMATE</a:t>
+              <a:t xml:space="preserve">Architecture had chosen the wall location, depth, and permitted penetrations. Those choices created a space in which plumbing Design would later occur.</a:t>
             </a:r>
           </a:p>
           <a:p>
@@ -1861,7 +1771,7 @@
           <a:p>
             <a:r>
               <a:rPr dirty="0"/>
-              <a:t>Sometimes the required plumbing fits. Good: the strategy afforded a workable tactic.</a:t>
+              <a:t xml:space="preserve">Now we are the plumbing designer.</a:t>
             </a:r>
           </a:p>
           <a:p>
@@ -1870,7 +1780,7 @@
           <a:p>
             <a:r>
               <a:rPr dirty="0"/>
-              <a:t>ANIMATE</a:t>
+              <a:t xml:space="preserve">ANIMATE</a:t>
             </a:r>
           </a:p>
           <a:p>
@@ -1879,7 +1789,7 @@
           <a:p>
             <a:r>
               <a:rPr dirty="0"/>
-              <a:t>Sometimes it does not.</a:t>
+              <a:t xml:space="preserve">Sometimes the required plumbing fits. Good: the strategy afforded a workable tactic.</a:t>
             </a:r>
           </a:p>
           <a:p>
@@ -1888,7 +1798,7 @@
           <a:p>
             <a:r>
               <a:rPr dirty="0"/>
-              <a:t>That is not merely a plumbing-design failure. It is information about the strategy we inherited. Perhaps the pipe can be rerouted. Perhaps the wall must move. Perhaps the requirement that created this pipe must change.</a:t>
+              <a:t xml:space="preserve">ANIMATE</a:t>
             </a:r>
           </a:p>
           <a:p>
@@ -1897,7 +1807,25 @@
           <a:p>
             <a:r>
               <a:rPr dirty="0"/>
-              <a:t>Design is therefore not just implementation planning. It is a test of whether Architecture's strategy can actually be realized.</a:t>
+              <a:t xml:space="preserve">Sometimes it does not.</a:t>
+            </a:r>
+          </a:p>
+          <a:p>
+            <a:endParaRPr dirty="0"/>
+          </a:p>
+          <a:p>
+            <a:r>
+              <a:rPr dirty="0"/>
+              <a:t xml:space="preserve">That is not merely a plumbing-design failure. It is information about the strategy we inherited. Perhaps the pipe can be rerouted. Perhaps the wall must move. Perhaps the requirement that created this pipe must change.</a:t>
+            </a:r>
+          </a:p>
+          <a:p>
+            <a:endParaRPr dirty="0"/>
+          </a:p>
+          <a:p>
+            <a:r>
+              <a:rPr dirty="0"/>
+              <a:t xml:space="preserve">Design is therefore not just implementation planning. It is a test of whether Architecture's strategy can actually be realized.</a:t>
             </a:r>
           </a:p>
         </p:txBody>
@@ -1911,7 +1839,7 @@
 </file>
 
 <file path=ppt/notesSlides/notesSlide24.xml><?xml version="1.0" encoding="utf-8"?>
-<p:notes xmlns:a="http://schemas.openxmlformats.org/drawingml/2006/main" xmlns:r="http://schemas.openxmlformats.org/officeDocument/2006/relationships" xmlns:p="http://schemas.openxmlformats.org/presentationml/2006/main">
+<p:notes xmlns:a="http://schemas.openxmlformats.org/drawingml/2006/main" xmlns:p="http://schemas.openxmlformats.org/presentationml/2006/main">
   <p:cSld>
     <p:spTree>
       <p:nvGrpSpPr>
@@ -1957,7 +1885,7 @@
           <a:p>
             <a:r>
               <a:rPr dirty="0"/>
-              <a:t>Architecture did not specify whether this interaction was synchronous or asynchronous. At first glance, that looks like a legitimate Design freedom.</a:t>
+              <a:t xml:space="preserve">- Apparent local freedom, no satisfactory local answer: escalate rather than torture the local design.</a:t>
             </a:r>
           </a:p>
           <a:p>
@@ -1966,7 +1894,7 @@
           <a:p>
             <a:r>
               <a:rPr dirty="0"/>
-              <a:t>ANIMATE</a:t>
+              <a:t xml:space="preserve">=====</a:t>
             </a:r>
           </a:p>
           <a:p>
@@ -1975,7 +1903,7 @@
           <a:p>
             <a:r>
               <a:rPr dirty="0"/>
-              <a:t>We try synchronous. It violates the failure-isolation or latency property Architecture was supposed to support.</a:t>
+              <a:t xml:space="preserve">Architecture did not specify whether this interaction was synchronous or asynchronous. At first glance, that looks like a legitimate Design freedom.</a:t>
             </a:r>
           </a:p>
           <a:p>
@@ -1984,7 +1912,7 @@
           <a:p>
             <a:r>
               <a:rPr dirty="0"/>
-              <a:t>ANIMATE</a:t>
+              <a:t xml:space="preserve">ANIMATE</a:t>
             </a:r>
           </a:p>
           <a:p>
@@ -1993,7 +1921,7 @@
           <a:p>
             <a:r>
               <a:rPr dirty="0"/>
-              <a:t>We try asynchronous. Now we cannot satisfy the consistency semantics the Specification requires.</a:t>
+              <a:t xml:space="preserve">We try synchronous. It violates the failure-isolation or latency property Architecture was supposed to support.</a:t>
             </a:r>
           </a:p>
           <a:p>
@@ -2002,7 +1930,7 @@
           <a:p>
             <a:r>
               <a:rPr dirty="0"/>
-              <a:t>ANIMATE</a:t>
+              <a:t xml:space="preserve">ANIMATE</a:t>
             </a:r>
           </a:p>
           <a:p>
@@ -2011,7 +1939,7 @@
           <a:p>
             <a:r>
               <a:rPr dirty="0"/>
-              <a:t>The important discovery is not that the designer needs a cleverer library. It is that the apparent degree of freedom was consequential.</a:t>
+              <a:t xml:space="preserve">We try asynchronous. Now we cannot satisfy the consistency semantics the Specification requires.</a:t>
             </a:r>
           </a:p>
           <a:p>
@@ -2020,7 +1948,7 @@
           <a:p>
             <a:r>
               <a:rPr dirty="0"/>
-              <a:t>ANIMATE</a:t>
+              <a:t xml:space="preserve">ANIMATE</a:t>
             </a:r>
           </a:p>
           <a:p>
@@ -2029,7 +1957,25 @@
           <a:p>
             <a:r>
               <a:rPr dirty="0"/>
-              <a:t>Detailed Design has discovered an architectural gap.</a:t>
+              <a:t xml:space="preserve">The important discovery is not that the designer needs a cleverer library. It is that the apparent degree of freedom was consequential.</a:t>
+            </a:r>
+          </a:p>
+          <a:p>
+            <a:endParaRPr dirty="0"/>
+          </a:p>
+          <a:p>
+            <a:r>
+              <a:rPr dirty="0"/>
+              <a:t xml:space="preserve">ANIMATE</a:t>
+            </a:r>
+          </a:p>
+          <a:p>
+            <a:endParaRPr dirty="0"/>
+          </a:p>
+          <a:p>
+            <a:r>
+              <a:rPr dirty="0"/>
+              <a:t xml:space="preserve">Detailed Design has discovered an architectural gap.</a:t>
             </a:r>
           </a:p>
         </p:txBody>
@@ -2043,7 +1989,7 @@
 </file>
 
 <file path=ppt/notesSlides/notesSlide25.xml><?xml version="1.0" encoding="utf-8"?>
-<p:notes xmlns:a="http://schemas.openxmlformats.org/drawingml/2006/main" xmlns:r="http://schemas.openxmlformats.org/officeDocument/2006/relationships" xmlns:p="http://schemas.openxmlformats.org/presentationml/2006/main">
+<p:notes xmlns:a="http://schemas.openxmlformats.org/drawingml/2006/main" xmlns:p="http://schemas.openxmlformats.org/presentationml/2006/main">
   <p:cSld>
     <p:spTree>
       <p:nvGrpSpPr>
@@ -2089,7 +2035,13 @@
           <a:p>
             <a:r>
               <a:rPr dirty="0"/>
-              <a:t>Here is the tempting alternative to escalation.</a:t>
+              <a:t xml:space="preserve">- The sharp point is epistemic: the model now gives wrong answers.</a:t>
+            </a:r>
+          </a:p>
+          <a:p>
+            <a:r>
+              <a:rPr dirty="0"/>
+              <a:t xml:space="preserve">- Degradation can begin on the first day of implementation.</a:t>
             </a:r>
           </a:p>
           <a:p>
@@ -2098,7 +2050,7 @@
           <a:p>
             <a:r>
               <a:rPr dirty="0"/>
-              <a:t>The architecture says A reaches B through this port. But the port makes today's feature inconvenient, so somebody reaches around it. Just this once.</a:t>
+              <a:t xml:space="preserve">=====</a:t>
             </a:r>
           </a:p>
           <a:p>
@@ -2107,7 +2059,7 @@
           <a:p>
             <a:r>
               <a:rPr dirty="0"/>
-              <a:t>ANIMATE</a:t>
+              <a:t xml:space="preserve">Here is the tempting alternative to escalation.</a:t>
             </a:r>
           </a:p>
           <a:p>
@@ -2116,7 +2068,7 @@
           <a:p>
             <a:r>
               <a:rPr dirty="0"/>
-              <a:t>The feature works. Tests pass.</a:t>
+              <a:t xml:space="preserve">The architecture says A reaches B through this port. But the port makes today's feature inconvenient, so somebody reaches around it. Just this once.</a:t>
             </a:r>
           </a:p>
           <a:p>
@@ -2125,7 +2077,7 @@
           <a:p>
             <a:r>
               <a:rPr dirty="0"/>
-              <a:t>ANIMATE</a:t>
+              <a:t xml:space="preserve">ANIMATE</a:t>
             </a:r>
           </a:p>
           <a:p>
@@ -2134,7 +2086,7 @@
           <a:p>
             <a:r>
               <a:rPr dirty="0"/>
-              <a:t>And the architecture is now false.</a:t>
+              <a:t xml:space="preserve">The feature works. Tests pass.</a:t>
             </a:r>
           </a:p>
           <a:p>
@@ -2143,7 +2095,7 @@
           <a:p>
             <a:r>
               <a:rPr dirty="0"/>
-              <a:t>That has a local cost: we introduced coupling. But the more interesting cost is epistemic.</a:t>
+              <a:t xml:space="preserve">ANIMATE</a:t>
             </a:r>
           </a:p>
           <a:p>
@@ -2152,7 +2104,7 @@
           <a:p>
             <a:r>
               <a:rPr dirty="0"/>
-              <a:t>Remember the Architecture lecture. We used dependency models to establish claims such as “no dependency crosses this boundary.” Once the implementation silently violates the model, that analysis can produce the wrong answer.</a:t>
+              <a:t xml:space="preserve">And the architecture is now false.</a:t>
             </a:r>
           </a:p>
           <a:p>
@@ -2161,7 +2113,7 @@
           <a:p>
             <a:r>
               <a:rPr dirty="0"/>
-              <a:t>ANIMATE</a:t>
+              <a:t xml:space="preserve">That has a local cost: we introduced coupling. But the more interesting cost is epistemic.</a:t>
             </a:r>
           </a:p>
           <a:p>
@@ -2170,7 +2122,7 @@
           <a:p>
             <a:r>
               <a:rPr dirty="0"/>
-              <a:t>Ask whether B can be replaced independently. The architecture says yes. The system says no.</a:t>
+              <a:t xml:space="preserve">Remember the Architecture lecture. We used dependency models to establish claims such as “no dependency crosses this boundary.” Once the implementation silently violates the model, that analysis can produce the wrong answer.</a:t>
             </a:r>
           </a:p>
           <a:p>
@@ -2179,7 +2131,7 @@
           <a:p>
             <a:r>
               <a:rPr dirty="0"/>
-              <a:t>Architectural degradation is therefore not merely untidy code or “technical debt.” It destroys the predictive value of the architectural knowledge we use to make engineering decisions.</a:t>
+              <a:t xml:space="preserve">ANIMATE</a:t>
             </a:r>
           </a:p>
           <a:p>
@@ -2188,7 +2140,25 @@
           <a:p>
             <a:r>
               <a:rPr dirty="0"/>
-              <a:t>And this can happen on the first day of implementation. We do not need ten years of legacy code to begin degrading an architecture.</a:t>
+              <a:t xml:space="preserve">Ask whether B can be replaced independently. The architecture says yes. The system says no.</a:t>
+            </a:r>
+          </a:p>
+          <a:p>
+            <a:endParaRPr dirty="0"/>
+          </a:p>
+          <a:p>
+            <a:r>
+              <a:rPr dirty="0"/>
+              <a:t xml:space="preserve">Architectural degradation is therefore not merely untidy code or “technical debt.” It destroys the predictive value of the architectural knowledge we use to make engineering decisions.</a:t>
+            </a:r>
+          </a:p>
+          <a:p>
+            <a:endParaRPr dirty="0"/>
+          </a:p>
+          <a:p>
+            <a:r>
+              <a:rPr dirty="0"/>
+              <a:t xml:space="preserve">And this can happen on the first day of implementation. We do not need ten years of legacy code to begin degrading an architecture.</a:t>
             </a:r>
           </a:p>
         </p:txBody>
@@ -2202,7 +2172,7 @@
 </file>
 
 <file path=ppt/notesSlides/notesSlide26.xml><?xml version="1.0" encoding="utf-8"?>
-<p:notes xmlns:a="http://schemas.openxmlformats.org/drawingml/2006/main" xmlns:r="http://schemas.openxmlformats.org/officeDocument/2006/relationships" xmlns:p="http://schemas.openxmlformats.org/presentationml/2006/main">
+<p:notes xmlns:a="http://schemas.openxmlformats.org/drawingml/2006/main" xmlns:p="http://schemas.openxmlformats.org/presentationml/2006/main">
   <p:cSld>
     <p:spTree>
       <p:nvGrpSpPr>
@@ -2248,7 +2218,13 @@
           <a:p>
             <a:r>
               <a:rPr dirty="0"/>
-              <a:t>Design is where many apparently free decisions first encounter reality.</a:t>
+              <a:t xml:space="preserve">- Route each discovery: local, environment-wide convention, Architecture, or Specification.</a:t>
+            </a:r>
+          </a:p>
+          <a:p>
+            <a:r>
+              <a:rPr dirty="0"/>
+              <a:t xml:space="preserve">- Workarounds: remove, model, or change the rule — never silently ignore.</a:t>
             </a:r>
           </a:p>
           <a:p>
@@ -2257,7 +2233,7 @@
           <a:p>
             <a:r>
               <a:rPr dirty="0"/>
-              <a:t>ANIMATE</a:t>
+              <a:t xml:space="preserve">=====</a:t>
             </a:r>
           </a:p>
           <a:p>
@@ -2266,7 +2242,7 @@
           <a:p>
             <a:r>
               <a:rPr dirty="0"/>
-              <a:t>Sometimes the answer really is local. Fine. Keep it local.</a:t>
+              <a:t xml:space="preserve">Design is where many apparently free decisions first encounter reality.</a:t>
             </a:r>
           </a:p>
           <a:p>
@@ -2275,7 +2251,7 @@
           <a:p>
             <a:r>
               <a:rPr dirty="0"/>
-              <a:t>ANIMATE</a:t>
+              <a:t xml:space="preserve">ANIMATE</a:t>
             </a:r>
           </a:p>
           <a:p>
@@ -2284,7 +2260,7 @@
           <a:p>
             <a:r>
               <a:rPr dirty="0"/>
-              <a:t>Sometimes we discover that every component needs the same answer. That does not necessarily mean drawing another box on the architecture diagram. It may mean capturing a convention or mechanism in the engineering environment: every handler is idempotent; every external dependency goes through an adapter; every cross-boundary call carries a deadline.</a:t>
+              <a:t xml:space="preserve">Sometimes the answer really is local. Fine. Keep it local.</a:t>
             </a:r>
           </a:p>
           <a:p>
@@ -2293,7 +2269,7 @@
           <a:p>
             <a:r>
               <a:rPr dirty="0"/>
-              <a:t>ANIMATE</a:t>
+              <a:t xml:space="preserve">ANIMATE</a:t>
             </a:r>
           </a:p>
           <a:p>
@@ -2302,7 +2278,7 @@
           <a:p>
             <a:r>
               <a:rPr dirty="0"/>
-              <a:t>Sometimes the consequence is structural and belongs in Architecture.</a:t>
+              <a:t xml:space="preserve">Sometimes we discover that every component needs the same answer. That does not necessarily mean drawing another box on the architecture diagram. It may mean capturing a convention or mechanism in the engineering environment: every handler is idempotent; every external dependency goes through an adapter; every cross-boundary call carries a deadline.</a:t>
             </a:r>
           </a:p>
           <a:p>
@@ -2311,7 +2287,7 @@
           <a:p>
             <a:r>
               <a:rPr dirty="0"/>
-              <a:t>ANIMATE</a:t>
+              <a:t xml:space="preserve">ANIMATE</a:t>
             </a:r>
           </a:p>
           <a:p>
@@ -2320,7 +2296,7 @@
           <a:p>
             <a:r>
               <a:rPr dirty="0"/>
-              <a:t>And sometimes we discover that what must be true was itself incomplete, and the feedback reaches Specification.</a:t>
+              <a:t xml:space="preserve">Sometimes the consequence is structural and belongs in Architecture.</a:t>
             </a:r>
           </a:p>
           <a:p>
@@ -2329,7 +2305,7 @@
           <a:p>
             <a:r>
               <a:rPr dirty="0"/>
-              <a:t>This is why a workaround cannot remain invisible. Remove it if it was a mistake. Model it if the architecture genuinely permits the exception. Change the rule if repeated exceptions tell us the rule was wrong.</a:t>
+              <a:t xml:space="preserve">ANIMATE</a:t>
             </a:r>
           </a:p>
           <a:p>
@@ -2338,7 +2314,25 @@
           <a:p>
             <a:r>
               <a:rPr dirty="0"/>
-              <a:t>Design discovers which apparent freedoms are actually consequential.</a:t>
+              <a:t xml:space="preserve">And sometimes we discover that what must be true was itself incomplete, and the feedback reaches Specification.</a:t>
+            </a:r>
+          </a:p>
+          <a:p>
+            <a:endParaRPr dirty="0"/>
+          </a:p>
+          <a:p>
+            <a:r>
+              <a:rPr dirty="0"/>
+              <a:t xml:space="preserve">This is why a workaround cannot remain invisible. Remove it if it was a mistake. Model it if the architecture genuinely permits the exception. Change the rule if repeated exceptions tell us the rule was wrong.</a:t>
+            </a:r>
+          </a:p>
+          <a:p>
+            <a:endParaRPr dirty="0"/>
+          </a:p>
+          <a:p>
+            <a:r>
+              <a:rPr dirty="0"/>
+              <a:t xml:space="preserve">Design discovers which apparent freedoms are actually consequential.</a:t>
             </a:r>
           </a:p>
         </p:txBody>
@@ -2352,7 +2346,7 @@
 </file>
 
 <file path=ppt/notesSlides/notesSlide27.xml><?xml version="1.0" encoding="utf-8"?>
-<p:notes xmlns:a="http://schemas.openxmlformats.org/drawingml/2006/main" xmlns:r="http://schemas.openxmlformats.org/officeDocument/2006/relationships" xmlns:p="http://schemas.openxmlformats.org/presentationml/2006/main">
+<p:notes xmlns:a="http://schemas.openxmlformats.org/drawingml/2006/main" xmlns:p="http://schemas.openxmlformats.org/presentationml/2006/main">
   <p:cSld>
     <p:spTree>
       <p:nvGrpSpPr>
@@ -2398,7 +2392,7 @@
           <a:p>
             <a:r>
               <a:rPr dirty="0"/>
-              <a:t>Architecture gave us a rule: if uncertainty could change the decision, consider buying information.</a:t>
+              <a:t xml:space="preserve">- Callback: Architecture’s “buy information”; implementation joins the menu as cheap evidence.</a:t>
             </a:r>
           </a:p>
           <a:p>
@@ -2407,7 +2401,7 @@
           <a:p>
             <a:r>
               <a:rPr dirty="0"/>
-              <a:t>Traditionally, implementation was often the most expensive possible way to buy that information.</a:t>
+              <a:t xml:space="preserve">=====</a:t>
             </a:r>
           </a:p>
           <a:p>
@@ -2416,7 +2410,25 @@
           <a:p>
             <a:r>
               <a:rPr dirty="0"/>
-              <a:t>What happens when implementation becomes cheap enough that we can use it as evidence before we commit to a Design?</a:t>
+              <a:t xml:space="preserve">Architecture gave us a rule: if uncertainty could change the decision, consider buying information.</a:t>
+            </a:r>
+          </a:p>
+          <a:p>
+            <a:endParaRPr dirty="0"/>
+          </a:p>
+          <a:p>
+            <a:r>
+              <a:rPr dirty="0"/>
+              <a:t xml:space="preserve">Traditionally, implementation was often the most expensive possible way to buy that information.</a:t>
+            </a:r>
+          </a:p>
+          <a:p>
+            <a:endParaRPr dirty="0"/>
+          </a:p>
+          <a:p>
+            <a:r>
+              <a:rPr dirty="0"/>
+              <a:t xml:space="preserve">What happens when implementation becomes cheap enough that we can use it as evidence before we commit to a Design?</a:t>
             </a:r>
           </a:p>
         </p:txBody>
@@ -2430,7 +2442,7 @@
 </file>
 
 <file path=ppt/notesSlides/notesSlide28.xml><?xml version="1.0" encoding="utf-8"?>
-<p:notes xmlns:a="http://schemas.openxmlformats.org/drawingml/2006/main" xmlns:r="http://schemas.openxmlformats.org/officeDocument/2006/relationships" xmlns:p="http://schemas.openxmlformats.org/presentationml/2006/main">
+<p:notes xmlns:a="http://schemas.openxmlformats.org/drawingml/2006/main" xmlns:p="http://schemas.openxmlformats.org/presentationml/2006/main">
   <p:cSld>
     <p:spTree>
       <p:nvGrpSpPr>
@@ -2476,7 +2488,7 @@
           <a:p>
             <a:r>
               <a:rPr dirty="0"/>
-              <a:t>At ordinary implementation speed, three related failures may occur weeks apart. Each one arrives with a local context and gets a local fix.</a:t>
+              <a:t xml:space="preserve">- Ground in the MAGE case without overclaiming: dense failures motivated a structural model; not a universal phase transition.</a:t>
             </a:r>
           </a:p>
           <a:p>
@@ -2485,7 +2497,7 @@
           <a:p>
             <a:r>
               <a:rPr dirty="0"/>
-              <a:t>ANIMATE</a:t>
+              <a:t xml:space="preserve">=====</a:t>
             </a:r>
           </a:p>
           <a:p>
@@ -2494,7 +2506,7 @@
           <a:p>
             <a:r>
               <a:rPr dirty="0"/>
-              <a:t>At much higher implementation velocity, the same family of failures can arrive in dense succession. Now the engineer can hold them in mind together and ask a different question: why do these keep happening?</a:t>
+              <a:t xml:space="preserve">At ordinary implementation speed, three related failures may occur weeks apart. Each one arrives with a local context and gets a local fix.</a:t>
             </a:r>
           </a:p>
           <a:p>
@@ -2503,7 +2515,7 @@
           <a:p>
             <a:r>
               <a:rPr dirty="0"/>
-              <a:t>That temporal compression can expose a common structural cause.</a:t>
+              <a:t xml:space="preserve">ANIMATE</a:t>
             </a:r>
           </a:p>
           <a:p>
@@ -2512,7 +2524,25 @@
           <a:p>
             <a:r>
               <a:rPr dirty="0"/>
-              <a:t>This is an inference we draw from the MAGE case study: the paper reports related failures surfacing in dense succession and motivating a new structural model and controls. I would not claim the paper proves a universal phase transition. The engineering opportunity is the important part.</a:t>
+              <a:t xml:space="preserve">At much higher implementation velocity, the same family of failures can arrive in dense succession. Now the engineer can hold them in mind together and ask a different question: why do these keep happening?</a:t>
+            </a:r>
+          </a:p>
+          <a:p>
+            <a:endParaRPr dirty="0"/>
+          </a:p>
+          <a:p>
+            <a:r>
+              <a:rPr dirty="0"/>
+              <a:t xml:space="preserve">That temporal compression can expose a common structural cause.</a:t>
+            </a:r>
+          </a:p>
+          <a:p>
+            <a:endParaRPr dirty="0"/>
+          </a:p>
+          <a:p>
+            <a:r>
+              <a:rPr dirty="0"/>
+              <a:t xml:space="preserve">This is an inference we draw from the MAGE case study: the paper reports related failures surfacing in dense succession and motivating a new structural model and controls. I would not claim the paper proves a universal phase transition. The engineering opportunity is the important part.</a:t>
             </a:r>
           </a:p>
         </p:txBody>
@@ -2526,7 +2556,7 @@
 </file>
 
 <file path=ppt/notesSlides/notesSlide29.xml><?xml version="1.0" encoding="utf-8"?>
-<p:notes xmlns:a="http://schemas.openxmlformats.org/drawingml/2006/main" xmlns:r="http://schemas.openxmlformats.org/officeDocument/2006/relationships" xmlns:p="http://schemas.openxmlformats.org/presentationml/2006/main">
+<p:notes xmlns:a="http://schemas.openxmlformats.org/drawingml/2006/main" xmlns:p="http://schemas.openxmlformats.org/presentationml/2006/main">
   <p:cSld>
     <p:spTree>
       <p:nvGrpSpPr>
@@ -2572,7 +2602,13 @@
           <a:p>
             <a:r>
               <a:rPr dirty="0"/>
-              <a:t>In Architecture, GenAI lowered the cost of evidence about architectural alternatives.</a:t>
+              <a:t xml:space="preserve">- Build order: economic (right) first, then epistemic (left).</a:t>
+            </a:r>
+          </a:p>
+          <a:p>
+            <a:r>
+              <a:rPr dirty="0"/>
+              <a:t xml:space="preserve">- Neither effect transfers judgment to the agent.</a:t>
             </a:r>
           </a:p>
           <a:p>
@@ -2581,7 +2617,7 @@
           <a:p>
             <a:r>
               <a:rPr dirty="0"/>
-              <a:t>Here the same economic change operates inside Design, but there is another effect.</a:t>
+              <a:t xml:space="preserve">=====</a:t>
             </a:r>
           </a:p>
           <a:p>
@@ -2590,7 +2626,7 @@
           <a:p>
             <a:r>
               <a:rPr dirty="0"/>
-              <a:t>ANIMATE</a:t>
+              <a:t xml:space="preserve">In Architecture, GenAI lowered the cost of evidence about architectural alternatives.</a:t>
             </a:r>
           </a:p>
           <a:p>
@@ -2599,7 +2635,7 @@
           <a:p>
             <a:r>
               <a:rPr dirty="0"/>
-              <a:t>On the right, the obvious economic effect: we can afford to implement competing tactics, prototype a data structure, measure a coordination mechanism, or perform a refactoring that previously would have been too expensive merely to learn from.</a:t>
+              <a:t xml:space="preserve">Here the same economic change operates inside Design, but there is another effect.</a:t>
             </a:r>
           </a:p>
           <a:p>
@@ -2608,7 +2644,7 @@
           <a:p>
             <a:r>
               <a:rPr dirty="0"/>
-              <a:t>ANIMATE</a:t>
+              <a:t xml:space="preserve">ANIMATE</a:t>
             </a:r>
           </a:p>
           <a:p>
@@ -2617,7 +2653,7 @@
           <a:p>
             <a:r>
               <a:rPr dirty="0"/>
-              <a:t>On the left is the subtler epistemic effect: velocity changes the temporal distribution of evidence. Related failures can become visible together.</a:t>
+              <a:t xml:space="preserve">On the right, the obvious economic effect: we can afford to implement competing tactics, prototype a data structure, measure a coordination mechanism, or perform a refactoring that previously would have been too expensive merely to learn from.</a:t>
             </a:r>
           </a:p>
           <a:p>
@@ -2626,7 +2662,7 @@
           <a:p>
             <a:r>
               <a:rPr dirty="0"/>
-              <a:t>ANIMATE</a:t>
+              <a:t xml:space="preserve">ANIMATE</a:t>
             </a:r>
           </a:p>
           <a:p>
@@ -2635,7 +2671,7 @@
           <a:p>
             <a:r>
               <a:rPr dirty="0"/>
-              <a:t>Neither effect transfers judgment to the agent. It changes what evidence is economically available to the engineer.</a:t>
+              <a:t xml:space="preserve">On the left is the subtler epistemic effect: velocity changes the temporal distribution of evidence. Related failures can become visible together.</a:t>
             </a:r>
           </a:p>
           <a:p>
@@ -2644,7 +2680,7 @@
           <a:p>
             <a:r>
               <a:rPr dirty="0"/>
-              <a:t>ANIMATE</a:t>
+              <a:t xml:space="preserve">ANIMATE</a:t>
             </a:r>
           </a:p>
           <a:p>
@@ -2653,7 +2689,25 @@
           <a:p>
             <a:r>
               <a:rPr dirty="0"/>
-              <a:t>Velocity does not merely let you implement the Design faster. It can let you reason about the Design differently.</a:t>
+              <a:t xml:space="preserve">Neither effect transfers judgment to the agent. It changes what evidence is economically available to the engineer.</a:t>
+            </a:r>
+          </a:p>
+          <a:p>
+            <a:endParaRPr dirty="0"/>
+          </a:p>
+          <a:p>
+            <a:r>
+              <a:rPr dirty="0"/>
+              <a:t xml:space="preserve">ANIMATE</a:t>
+            </a:r>
+          </a:p>
+          <a:p>
+            <a:endParaRPr dirty="0"/>
+          </a:p>
+          <a:p>
+            <a:r>
+              <a:rPr dirty="0"/>
+              <a:t xml:space="preserve">Velocity does not merely let you implement the Design faster. It can let you reason about the Design differently.</a:t>
             </a:r>
           </a:p>
         </p:txBody>
@@ -2667,7 +2721,7 @@
 </file>
 
 <file path=ppt/notesSlides/notesSlide3.xml><?xml version="1.0" encoding="utf-8"?>
-<p:notes xmlns:a="http://schemas.openxmlformats.org/drawingml/2006/main" xmlns:r="http://schemas.openxmlformats.org/officeDocument/2006/relationships" xmlns:p="http://schemas.openxmlformats.org/presentationml/2006/main">
+<p:notes xmlns:a="http://schemas.openxmlformats.org/drawingml/2006/main" xmlns:p="http://schemas.openxmlformats.org/presentationml/2006/main">
   <p:cSld>
     <p:spTree>
       <p:nvGrpSpPr>
@@ -2713,7 +2767,7 @@
           <a:p>
             <a:r>
               <a:rPr dirty="0"/>
-              <a:t>15–20 seconds only.</a:t>
+              <a:t xml:space="preserve">- 15–20 seconds only.</a:t>
             </a:r>
           </a:p>
         </p:txBody>
@@ -2727,7 +2781,7 @@
 </file>
 
 <file path=ppt/notesSlides/notesSlide30.xml><?xml version="1.0" encoding="utf-8"?>
-<p:notes xmlns:a="http://schemas.openxmlformats.org/drawingml/2006/main" xmlns:r="http://schemas.openxmlformats.org/officeDocument/2006/relationships" xmlns:p="http://schemas.openxmlformats.org/presentationml/2006/main">
+<p:notes xmlns:a="http://schemas.openxmlformats.org/drawingml/2006/main" xmlns:p="http://schemas.openxmlformats.org/presentationml/2006/main">
   <p:cSld>
     <p:spTree>
       <p:nvGrpSpPr>
@@ -2773,16 +2827,13 @@
           <a:p>
             <a:r>
               <a:rPr dirty="0"/>
-              <a:t>Explain the deliverable and immediately move.</a:t>
-            </a:r>
-          </a:p>
-          <a:p>
-            <a:endParaRPr dirty="0"/>
+              <a:t xml:space="preserve">- Explain the deliverable and immediately move; do not overload.</a:t>
+            </a:r>
           </a:p>
           <a:p>
             <a:r>
               <a:rPr dirty="0"/>
-              <a:t>Give them one architectural component — the Advice Service — with its responsibility, interface, inherited constraints, and 2–3 engineering-environment conventions. Do not overload.</a:t>
+              <a:t xml:space="preserve">- One component — the Advice Service — with responsibility, interface, inherited constraints, and 2–3 environment conventions.</a:t>
             </a:r>
           </a:p>
         </p:txBody>
@@ -2796,7 +2847,7 @@
 </file>
 
 <file path=ppt/notesSlides/notesSlide31.xml><?xml version="1.0" encoding="utf-8"?>
-<p:notes xmlns:a="http://schemas.openxmlformats.org/drawingml/2006/main" xmlns:r="http://schemas.openxmlformats.org/officeDocument/2006/relationships" xmlns:p="http://schemas.openxmlformats.org/presentationml/2006/main">
+<p:notes xmlns:a="http://schemas.openxmlformats.org/drawingml/2006/main" xmlns:p="http://schemas.openxmlformats.org/presentationml/2006/main">
   <p:cSld>
     <p:spTree>
       <p:nvGrpSpPr>
@@ -2842,25 +2893,13 @@
           <a:p>
             <a:r>
               <a:rPr dirty="0"/>
-              <a:t>Teams identify remaining degrees of freedom and classify them FOLLOW / CHOOSE / ESCALATE. About 3 minutes.</a:t>
-            </a:r>
-          </a:p>
-          <a:p>
-            <a:endParaRPr dirty="0"/>
+              <a:t xml:space="preserve">- Classify remaining freedoms FOLLOW / CHOOSE / ESCALATE before answering any; ~3 minutes.</a:t>
+            </a:r>
           </a:p>
           <a:p>
             <a:r>
               <a:rPr dirty="0"/>
-              <a:t>Prompt: List the open questions inside this component. Classify each before answering it.</a:t>
-            </a:r>
-          </a:p>
-          <a:p>
-            <a:endParaRPr dirty="0"/>
-          </a:p>
-          <a:p>
-            <a:r>
-              <a:rPr dirty="0"/>
-              <a:t>Examples should not be prefilled initially; reveal them after 2–3 minutes as discussion scaffolding.</a:t>
+              <a:t xml:space="preserve">- Do not prefill examples; reveal them after 2–3 minutes as scaffolding.</a:t>
             </a:r>
           </a:p>
         </p:txBody>
@@ -2874,7 +2913,7 @@
 </file>
 
 <file path=ppt/notesSlides/notesSlide32.xml><?xml version="1.0" encoding="utf-8"?>
-<p:notes xmlns:a="http://schemas.openxmlformats.org/drawingml/2006/main" xmlns:r="http://schemas.openxmlformats.org/officeDocument/2006/relationships" xmlns:p="http://schemas.openxmlformats.org/presentationml/2006/main">
+<p:notes xmlns:a="http://schemas.openxmlformats.org/drawingml/2006/main" xmlns:p="http://schemas.openxmlformats.org/presentationml/2006/main">
   <p:cSld>
     <p:spTree>
       <p:nvGrpSpPr>
@@ -2920,34 +2959,13 @@
           <a:p>
             <a:r>
               <a:rPr dirty="0"/>
-              <a:t>Force alternatives before convergence. Each needs a purposeful representation/model that supports a relevant claim. About 7 minutes.</a:t>
-            </a:r>
-          </a:p>
-          <a:p>
-            <a:endParaRPr dirty="0"/>
+              <a:t xml:space="preserve">- Force alternatives before convergence; each design carries one purposeful model; ~7 minutes.</a:t>
+            </a:r>
           </a:p>
           <a:p>
             <a:r>
               <a:rPr dirty="0"/>
-              <a:t>Prompt: Two genuinely different tactics. Both must respect what you inherited.</a:t>
-            </a:r>
-          </a:p>
-          <a:p>
-            <a:endParaRPr dirty="0"/>
-          </a:p>
-          <a:p>
-            <a:r>
-              <a:rPr dirty="0"/>
-              <a:t>Require: internal parts/responsibilities; key interactions/state; one purposeful model; expected consequence/tradeoff.</a:t>
-            </a:r>
-          </a:p>
-          <a:p>
-            <a:endParaRPr dirty="0"/>
-          </a:p>
-          <a:p>
-            <a:r>
-              <a:rPr dirty="0"/>
-              <a:t>Do not converge yet.</a:t>
+              <a:t xml:space="preserve">- Require: parts and responsibilities, interactions and state, one model, one expected tradeoff.</a:t>
             </a:r>
           </a:p>
         </p:txBody>
@@ -2961,7 +2979,7 @@
 </file>
 
 <file path=ppt/notesSlides/notesSlide33.xml><?xml version="1.0" encoding="utf-8"?>
-<p:notes xmlns:a="http://schemas.openxmlformats.org/drawingml/2006/main" xmlns:r="http://schemas.openxmlformats.org/officeDocument/2006/relationships" xmlns:p="http://schemas.openxmlformats.org/presentationml/2006/main">
+<p:notes xmlns:a="http://schemas.openxmlformats.org/drawingml/2006/main" xmlns:p="http://schemas.openxmlformats.org/presentationml/2006/main">
   <p:cSld>
     <p:spTree>
       <p:nvGrpSpPr>
@@ -3007,16 +3025,7 @@
           <a:p>
             <a:r>
               <a:rPr dirty="0"/>
-              <a:t>Choose and defend: obligations, inherited architecture, environment, genuine tradeoff, evidence/model, anything that should feed upward.</a:t>
-            </a:r>
-          </a:p>
-          <a:p>
-            <a:endParaRPr dirty="0"/>
-          </a:p>
-          <a:p>
-            <a:r>
-              <a:rPr dirty="0"/>
-              <a:t>About 6 minutes including selected shares.</a:t>
+              <a:t xml:space="preserve">- Defend against Specification, Architecture, environment; name the genuine tradeoff, what the model establishes, and anything to escalate; ~6 minutes including shares.</a:t>
             </a:r>
           </a:p>
         </p:txBody>
@@ -3030,7 +3039,7 @@
 </file>
 
 <file path=ppt/notesSlides/notesSlide34.xml><?xml version="1.0" encoding="utf-8"?>
-<p:notes xmlns:a="http://schemas.openxmlformats.org/drawingml/2006/main" xmlns:r="http://schemas.openxmlformats.org/officeDocument/2006/relationships" xmlns:p="http://schemas.openxmlformats.org/presentationml/2006/main">
+<p:notes xmlns:a="http://schemas.openxmlformats.org/drawingml/2006/main" xmlns:p="http://schemas.openxmlformats.org/presentationml/2006/main">
   <p:cSld>
     <p:spTree>
       <p:nvGrpSpPr>
@@ -3076,25 +3085,13 @@
           <a:p>
             <a:r>
               <a:rPr dirty="0"/>
-              <a:t>Whole-room debrief. Which freedoms were genuinely local? Which were already answered? Which revealed a shared convention or an architectural/specification question? About 4 minutes.</a:t>
-            </a:r>
-          </a:p>
-          <a:p>
-            <a:endParaRPr dirty="0"/>
+              <a:t xml:space="preserve">- Whole-room debrief: sort discoveries into FOLLOW / CHOOSE / ENVIRONMENT / ARCHITECTURE / SPECIFICATION.</a:t>
+            </a:r>
           </a:p>
           <a:p>
             <a:r>
               <a:rPr dirty="0"/>
-              <a:t>Ask teams for examples to populate verbally.</a:t>
-            </a:r>
-          </a:p>
-          <a:p>
-            <a:endParaRPr dirty="0"/>
-          </a:p>
-          <a:p>
-            <a:r>
-              <a:rPr dirty="0"/>
-              <a:t>Design produces an implementation plan and evidence about the decisions above it.</a:t>
+              <a:t xml:space="preserve">- Ask teams for examples to populate verbally.</a:t>
             </a:r>
           </a:p>
         </p:txBody>
@@ -3108,7 +3105,7 @@
 </file>
 
 <file path=ppt/notesSlides/notesSlide35.xml><?xml version="1.0" encoding="utf-8"?>
-<p:notes xmlns:a="http://schemas.openxmlformats.org/drawingml/2006/main" xmlns:r="http://schemas.openxmlformats.org/officeDocument/2006/relationships" xmlns:p="http://schemas.openxmlformats.org/presentationml/2006/main">
+<p:notes xmlns:a="http://schemas.openxmlformats.org/drawingml/2006/main" xmlns:p="http://schemas.openxmlformats.org/presentationml/2006/main">
   <p:cSld>
     <p:spTree>
       <p:nvGrpSpPr>
@@ -3154,7 +3151,13 @@
           <a:p>
             <a:r>
               <a:rPr dirty="0"/>
-              <a:t>We now have the complete downward progression.</a:t>
+              <a:t xml:space="preserve">- Constraints flow down; evidence flows up.</a:t>
+            </a:r>
+          </a:p>
+          <a:p>
+            <a:r>
+              <a:rPr dirty="0"/>
+              <a:t xml:space="preserve">- Implementation is the terminal case — no fourth verbose definition.</a:t>
             </a:r>
           </a:p>
           <a:p>
@@ -3163,7 +3166,7 @@
           <a:p>
             <a:r>
               <a:rPr dirty="0"/>
-              <a:t>Specification narrows the space of acceptable systems.</a:t>
+              <a:t xml:space="preserve">=====</a:t>
             </a:r>
           </a:p>
           <a:p>
@@ -3172,7 +3175,7 @@
           <a:p>
             <a:r>
               <a:rPr dirty="0"/>
-              <a:t>Architecture chooses consequential organization for one of them and deliberately treats its major parts as units.</a:t>
+              <a:t xml:space="preserve">We now have the complete downward progression.</a:t>
             </a:r>
           </a:p>
           <a:p>
@@ -3181,7 +3184,7 @@
           <a:p>
             <a:r>
               <a:rPr dirty="0"/>
-              <a:t>Design opens those units and chooses how they realize their responsibilities.</a:t>
+              <a:t xml:space="preserve">Specification narrows the space of acceptable systems.</a:t>
             </a:r>
           </a:p>
           <a:p>
@@ -3190,7 +3193,7 @@
           <a:p>
             <a:r>
               <a:rPr dirty="0"/>
-              <a:t>If what we open is still too large to reason about directly, the process recurs. We may establish another architecture at that scope and design within it.</a:t>
+              <a:t xml:space="preserve">Architecture chooses consequential organization for one of them and deliberately treats its major parts as units.</a:t>
             </a:r>
           </a:p>
           <a:p>
@@ -3199,7 +3202,7 @@
           <a:p>
             <a:r>
               <a:rPr dirty="0"/>
-              <a:t>Eventually the entities are small enough to reason about directly. Further decomposition no longer buys useful understanding. We implement them.</a:t>
+              <a:t xml:space="preserve">Design opens those units and chooses how they realize their responsibilities.</a:t>
             </a:r>
           </a:p>
           <a:p>
@@ -3208,7 +3211,7 @@
           <a:p>
             <a:r>
               <a:rPr dirty="0"/>
-              <a:t>But notice the arrows are not only downward. Detailed work produces evidence. Design may reveal an architectural gap; implementation may reveal a Design error; experience may reveal that an apparent freedom should become durable engineering knowledge.</a:t>
+              <a:t xml:space="preserve">If what we open is still too large to reason about directly, the process recurs. We may establish another architecture at that scope and design within it.</a:t>
             </a:r>
           </a:p>
           <a:p>
@@ -3217,7 +3220,25 @@
           <a:p>
             <a:r>
               <a:rPr dirty="0"/>
-              <a:t>Engineering proceeds downward through constraints and upward through evidence.</a:t>
+              <a:t xml:space="preserve">Eventually the entities are small enough to reason about directly. Further decomposition no longer buys useful understanding. We implement them.</a:t>
+            </a:r>
+          </a:p>
+          <a:p>
+            <a:endParaRPr dirty="0"/>
+          </a:p>
+          <a:p>
+            <a:r>
+              <a:rPr dirty="0"/>
+              <a:t xml:space="preserve">But notice the arrows are not only downward. Detailed work produces evidence. Design may reveal an architectural gap; implementation may reveal a Design error; experience may reveal that an apparent freedom should become durable engineering knowledge.</a:t>
+            </a:r>
+          </a:p>
+          <a:p>
+            <a:endParaRPr dirty="0"/>
+          </a:p>
+          <a:p>
+            <a:r>
+              <a:rPr dirty="0"/>
+              <a:t xml:space="preserve">Engineering proceeds downward through constraints and upward through evidence.</a:t>
             </a:r>
           </a:p>
         </p:txBody>
@@ -3231,7 +3252,7 @@
 </file>
 
 <file path=ppt/notesSlides/notesSlide36.xml><?xml version="1.0" encoding="utf-8"?>
-<p:notes xmlns:a="http://schemas.openxmlformats.org/drawingml/2006/main" xmlns:r="http://schemas.openxmlformats.org/officeDocument/2006/relationships" xmlns:p="http://schemas.openxmlformats.org/presentationml/2006/main">
+<p:notes xmlns:a="http://schemas.openxmlformats.org/drawingml/2006/main" xmlns:p="http://schemas.openxmlformats.org/presentationml/2006/main">
   <p:cSld>
     <p:spTree>
       <p:nvGrpSpPr>
@@ -3277,7 +3298,7 @@
           <a:p>
             <a:r>
               <a:rPr dirty="0"/>
-              <a:t>Architecture is strategy. Design is tactics.</a:t>
+              <a:t xml:space="preserve">- Land the two sentences and stop; no third slogan.</a:t>
             </a:r>
           </a:p>
           <a:p>
@@ -3286,7 +3307,7 @@
           <a:p>
             <a:r>
               <a:rPr dirty="0"/>
-              <a:t>But that relationship is not one-way. Architecture creates the space within which Design works. Design supplies evidence about whether that space actually permits a satisfactory solution.</a:t>
+              <a:t xml:space="preserve">=====</a:t>
             </a:r>
           </a:p>
           <a:p>
@@ -3295,7 +3316,7 @@
           <a:p>
             <a:r>
               <a:rPr dirty="0"/>
-              <a:t>That is why good Design is neither unconstrained creativity nor mechanical implementation of somebody else's boxes.</a:t>
+              <a:t xml:space="preserve">Architecture is strategy. Design is tactics.</a:t>
             </a:r>
           </a:p>
           <a:p>
@@ -3304,7 +3325,7 @@
           <a:p>
             <a:r>
               <a:rPr dirty="0"/>
-              <a:t>It is engineering within inherited constraints, with enough judgment to recognize when those constraints themselves need to change.</a:t>
+              <a:t xml:space="preserve">But that relationship is not one-way. Architecture creates the space within which Design works. Design supplies evidence about whether that space actually permits a satisfactory solution.</a:t>
             </a:r>
           </a:p>
           <a:p>
@@ -3313,7 +3334,7 @@
           <a:p>
             <a:r>
               <a:rPr dirty="0"/>
-              <a:t>Architecture constrains the available tactics. Design tests whether the strategy is workable.</a:t>
+              <a:t xml:space="preserve">That is why good Design is neither unconstrained creativity nor mechanical implementation of somebody else's boxes.</a:t>
             </a:r>
           </a:p>
           <a:p>
@@ -3322,7 +3343,25 @@
           <a:p>
             <a:r>
               <a:rPr dirty="0"/>
-              <a:t>And stop.</a:t>
+              <a:t xml:space="preserve">It is engineering within inherited constraints, with enough judgment to recognize when those constraints themselves need to change.</a:t>
+            </a:r>
+          </a:p>
+          <a:p>
+            <a:endParaRPr dirty="0"/>
+          </a:p>
+          <a:p>
+            <a:r>
+              <a:rPr dirty="0"/>
+              <a:t xml:space="preserve">Architecture constrains the available tactics. Design tests whether the strategy is workable.</a:t>
+            </a:r>
+          </a:p>
+          <a:p>
+            <a:endParaRPr dirty="0"/>
+          </a:p>
+          <a:p>
+            <a:r>
+              <a:rPr dirty="0"/>
+              <a:t xml:space="preserve">And stop.</a:t>
             </a:r>
           </a:p>
         </p:txBody>
@@ -3336,7 +3375,7 @@
 </file>
 
 <file path=ppt/notesSlides/notesSlide4.xml><?xml version="1.0" encoding="utf-8"?>
-<p:notes xmlns:a="http://schemas.openxmlformats.org/drawingml/2006/main" xmlns:r="http://schemas.openxmlformats.org/officeDocument/2006/relationships" xmlns:p="http://schemas.openxmlformats.org/presentationml/2006/main">
+<p:notes xmlns:a="http://schemas.openxmlformats.org/drawingml/2006/main" xmlns:p="http://schemas.openxmlformats.org/presentationml/2006/main">
   <p:cSld>
     <p:spTree>
       <p:nvGrpSpPr>
@@ -3382,7 +3421,7 @@
           <a:p>
             <a:r>
               <a:rPr dirty="0"/>
-              <a:t>Architecture deliberately let us ignore this component's internals. That compression was useful: we could reason about system-wide structure without simultaneously reasoning about every object and function.</a:t>
+              <a:t xml:space="preserve">- Responsibility, interface, and obligations survive the opening; only the internals are new work.</a:t>
             </a:r>
           </a:p>
           <a:p>
@@ -3391,7 +3430,7 @@
           <a:p>
             <a:r>
               <a:rPr dirty="0"/>
-              <a:t>Design removes that abstraction boundary for us.</a:t>
+              <a:t xml:space="preserve">=====</a:t>
             </a:r>
           </a:p>
           <a:p>
@@ -3400,7 +3439,7 @@
           <a:p>
             <a:r>
               <a:rPr dirty="0"/>
-              <a:t>ANIMATE</a:t>
+              <a:t xml:space="preserve">Architecture deliberately let us ignore this component's internals. That compression was useful: we could reason about system-wide structure without simultaneously reasoning about every object and function.</a:t>
             </a:r>
           </a:p>
           <a:p>
@@ -3409,7 +3448,7 @@
           <a:p>
             <a:r>
               <a:rPr dirty="0"/>
-              <a:t>The responsibility does not disappear. The interface does not disappear. The obligations that motivated them do not disappear.</a:t>
+              <a:t xml:space="preserve">Design removes that abstraction boundary for us.</a:t>
             </a:r>
           </a:p>
           <a:p>
@@ -3418,7 +3457,7 @@
           <a:p>
             <a:r>
               <a:rPr dirty="0"/>
-              <a:t>What changes is that the inside is now our engineering problem.</a:t>
+              <a:t xml:space="preserve">ANIMATE</a:t>
             </a:r>
           </a:p>
           <a:p>
@@ -3427,7 +3466,7 @@
           <a:p>
             <a:r>
               <a:rPr dirty="0"/>
-              <a:t>ANIMATE</a:t>
+              <a:t xml:space="preserve">The responsibility does not disappear. The interface does not disappear. The obligations that motivated them do not disappear.</a:t>
             </a:r>
           </a:p>
           <a:p>
@@ -3436,7 +3475,25 @@
           <a:p>
             <a:r>
               <a:rPr dirty="0"/>
-              <a:t>So Design is not greenfield invention inside an empty rectangle. We open the box carrying decisions with us.</a:t>
+              <a:t xml:space="preserve">What changes is that the inside is now our engineering problem.</a:t>
+            </a:r>
+          </a:p>
+          <a:p>
+            <a:endParaRPr dirty="0"/>
+          </a:p>
+          <a:p>
+            <a:r>
+              <a:rPr dirty="0"/>
+              <a:t xml:space="preserve">ANIMATE</a:t>
+            </a:r>
+          </a:p>
+          <a:p>
+            <a:endParaRPr dirty="0"/>
+          </a:p>
+          <a:p>
+            <a:r>
+              <a:rPr dirty="0"/>
+              <a:t xml:space="preserve">So Design is not greenfield invention inside an empty rectangle. We open the box carrying decisions with us.</a:t>
             </a:r>
           </a:p>
         </p:txBody>
@@ -3450,7 +3507,7 @@
 </file>
 
 <file path=ppt/notesSlides/notesSlide5.xml><?xml version="1.0" encoding="utf-8"?>
-<p:notes xmlns:a="http://schemas.openxmlformats.org/drawingml/2006/main" xmlns:r="http://schemas.openxmlformats.org/officeDocument/2006/relationships" xmlns:p="http://schemas.openxmlformats.org/presentationml/2006/main">
+<p:notes xmlns:a="http://schemas.openxmlformats.org/drawingml/2006/main" xmlns:p="http://schemas.openxmlformats.org/presentationml/2006/main">
   <p:cSld>
     <p:spTree>
       <p:nvGrpSpPr>
@@ -3496,7 +3553,13 @@
           <a:p>
             <a:r>
               <a:rPr dirty="0"/>
-              <a:t>Two sources should now be familiar.</a:t>
+              <a:t xml:space="preserve">- Spend the real time on the engineering environment — the novel third source.</a:t>
+            </a:r>
+          </a:p>
+          <a:p>
+            <a:r>
+              <a:rPr dirty="0"/>
+              <a:t xml:space="preserve">- Examples: repositories, injected dependencies, deadlines on cross-service calls, standard queue with retry and dead-letter.</a:t>
             </a:r>
           </a:p>
           <a:p>
@@ -3505,7 +3568,7 @@
           <a:p>
             <a:r>
               <a:rPr dirty="0"/>
-              <a:t>ANIMATE</a:t>
+              <a:t xml:space="preserve">=====</a:t>
             </a:r>
           </a:p>
           <a:p>
@@ -3514,7 +3577,7 @@
           <a:p>
             <a:r>
               <a:rPr dirty="0"/>
-              <a:t>The Specification tells us what must remain true.</a:t>
+              <a:t xml:space="preserve">Two sources should now be familiar.</a:t>
             </a:r>
           </a:p>
           <a:p>
@@ -3523,7 +3586,7 @@
           <a:p>
             <a:r>
               <a:rPr dirty="0"/>
-              <a:t>ANIMATE</a:t>
+              <a:t xml:space="preserve">ANIMATE</a:t>
             </a:r>
           </a:p>
           <a:p>
@@ -3532,7 +3595,7 @@
           <a:p>
             <a:r>
               <a:rPr dirty="0"/>
-              <a:t>Architecture tells us what this part is responsible for and how it fits into the larger strategy.</a:t>
+              <a:t xml:space="preserve">The Specification tells us what must remain true.</a:t>
             </a:r>
           </a:p>
           <a:p>
@@ -3541,7 +3604,7 @@
           <a:p>
             <a:r>
               <a:rPr dirty="0"/>
-              <a:t>ANIMATE</a:t>
+              <a:t xml:space="preserve">ANIMATE</a:t>
             </a:r>
           </a:p>
           <a:p>
@@ -3550,7 +3613,7 @@
           <a:p>
             <a:r>
               <a:rPr dirty="0"/>
-              <a:t>But there is a third source engineers often leave implicit: the engineering environment.</a:t>
+              <a:t xml:space="preserve">Architecture tells us what this part is responsible for and how it fits into the larger strategy.</a:t>
             </a:r>
           </a:p>
           <a:p>
@@ -3559,7 +3622,7 @@
           <a:p>
             <a:r>
               <a:rPr dirty="0"/>
-              <a:t>Suppose this organization already says all persistent state goes through repositories. Or all dependencies are injected. Or cross-service calls carry deadlines. Or asynchronous work uses the standard queue with its standard retry and dead-letter behavior.</a:t>
+              <a:t xml:space="preserve">ANIMATE</a:t>
             </a:r>
           </a:p>
           <a:p>
@@ -3568,7 +3631,7 @@
           <a:p>
             <a:r>
               <a:rPr dirty="0"/>
-              <a:t>ANIMATE</a:t>
+              <a:t xml:space="preserve">But there is a third source engineers often leave implicit: the engineering environment.</a:t>
             </a:r>
           </a:p>
           <a:p>
@@ -3577,7 +3640,7 @@
           <a:p>
             <a:r>
               <a:rPr dirty="0"/>
-              <a:t>Those are not necessarily facts we would put on the architecture diagram. But they mean the designer is not choosing from the entire universe of software mechanisms.</a:t>
+              <a:t xml:space="preserve">Suppose this organization already says all persistent state goes through repositories. Or all dependencies are injected. Or cross-service calls carry deadlines. Or asynchronous work uses the standard queue with its standard retry and dead-letter behavior.</a:t>
             </a:r>
           </a:p>
           <a:p>
@@ -3586,7 +3649,25 @@
           <a:p>
             <a:r>
               <a:rPr dirty="0"/>
-              <a:t>Good engineering environments deliberately answer recurring questions so every component designer does not have to rediscover an answer.</a:t>
+              <a:t xml:space="preserve">ANIMATE</a:t>
+            </a:r>
+          </a:p>
+          <a:p>
+            <a:endParaRPr dirty="0"/>
+          </a:p>
+          <a:p>
+            <a:r>
+              <a:rPr dirty="0"/>
+              <a:t xml:space="preserve">Those are not necessarily facts we would put on the architecture diagram. But they mean the designer is not choosing from the entire universe of software mechanisms.</a:t>
+            </a:r>
+          </a:p>
+          <a:p>
+            <a:endParaRPr dirty="0"/>
+          </a:p>
+          <a:p>
+            <a:r>
+              <a:rPr dirty="0"/>
+              <a:t xml:space="preserve">Good engineering environments deliberately answer recurring questions so every component designer does not have to rediscover an answer.</a:t>
             </a:r>
           </a:p>
         </p:txBody>
@@ -3600,7 +3681,7 @@
 </file>
 
 <file path=ppt/notesSlides/notesSlide6.xml><?xml version="1.0" encoding="utf-8"?>
-<p:notes xmlns:a="http://schemas.openxmlformats.org/drawingml/2006/main" xmlns:r="http://schemas.openxmlformats.org/officeDocument/2006/relationships" xmlns:p="http://schemas.openxmlformats.org/presentationml/2006/main">
+<p:notes xmlns:a="http://schemas.openxmlformats.org/drawingml/2006/main" xmlns:p="http://schemas.openxmlformats.org/presentationml/2006/main">
   <p:cSld>
     <p:spTree>
       <p:nvGrpSpPr>
@@ -3646,7 +3727,13 @@
           <a:p>
             <a:r>
               <a:rPr dirty="0"/>
-              <a:t>Remember Degrees of Freedom from Specification. Every consequential decision removes alternatives from the realization space.</a:t>
+              <a:t xml:space="preserve">- Callback: Degrees of Freedom from Specification.</a:t>
+            </a:r>
+          </a:p>
+          <a:p>
+            <a:r>
+              <a:rPr dirty="0"/>
+              <a:t xml:space="preserve">- Not “what could I possibly implement?” but “which consequential choices are still open?”</a:t>
             </a:r>
           </a:p>
           <a:p>
@@ -3655,7 +3742,7 @@
           <a:p>
             <a:r>
               <a:rPr dirty="0"/>
-              <a:t>The same idea now applies inside one component.</a:t>
+              <a:t xml:space="preserve">=====</a:t>
             </a:r>
           </a:p>
           <a:p>
@@ -3664,7 +3751,7 @@
           <a:p>
             <a:r>
               <a:rPr dirty="0"/>
-              <a:t>Specification removes choices inconsistent with our obligations. Architecture removes choices inconsistent with the system strategy. The engineering environment removes choices the organization has already standardized.</a:t>
+              <a:t xml:space="preserve">Remember Degrees of Freedom from Specification. Every consequential decision removes alternatives from the realization space.</a:t>
             </a:r>
           </a:p>
           <a:p>
@@ -3673,7 +3760,7 @@
           <a:p>
             <a:r>
               <a:rPr dirty="0"/>
-              <a:t>What remains is the local Design space.</a:t>
+              <a:t xml:space="preserve">The same idea now applies inside one component.</a:t>
             </a:r>
           </a:p>
           <a:p>
@@ -3682,7 +3769,25 @@
           <a:p>
             <a:r>
               <a:rPr dirty="0"/>
-              <a:t>The important question is not “what could I possibly implement?” It is “which consequential choices are actually still open?”</a:t>
+              <a:t xml:space="preserve">Specification removes choices inconsistent with our obligations. Architecture removes choices inconsistent with the system strategy. The engineering environment removes choices the organization has already standardized.</a:t>
+            </a:r>
+          </a:p>
+          <a:p>
+            <a:endParaRPr dirty="0"/>
+          </a:p>
+          <a:p>
+            <a:r>
+              <a:rPr dirty="0"/>
+              <a:t xml:space="preserve">What remains is the local Design space.</a:t>
+            </a:r>
+          </a:p>
+          <a:p>
+            <a:endParaRPr dirty="0"/>
+          </a:p>
+          <a:p>
+            <a:r>
+              <a:rPr dirty="0"/>
+              <a:t xml:space="preserve">The important question is not “what could I possibly implement?” It is “which consequential choices are actually still open?”</a:t>
             </a:r>
           </a:p>
         </p:txBody>
@@ -3696,7 +3801,7 @@
 </file>
 
 <file path=ppt/notesSlides/notesSlide7.xml><?xml version="1.0" encoding="utf-8"?>
-<p:notes xmlns:a="http://schemas.openxmlformats.org/drawingml/2006/main" xmlns:r="http://schemas.openxmlformats.org/officeDocument/2006/relationships" xmlns:p="http://schemas.openxmlformats.org/presentationml/2006/main">
+<p:notes xmlns:a="http://schemas.openxmlformats.org/drawingml/2006/main" xmlns:p="http://schemas.openxmlformats.org/presentationml/2006/main">
   <p:cSld>
     <p:spTree>
       <p:nvGrpSpPr>
@@ -3742,7 +3847,7 @@
           <a:p>
             <a:r>
               <a:rPr dirty="0"/>
-              <a:t>ANIMATE</a:t>
+              <a:t xml:space="preserve">- One example per move: follow (retry mechanism), choose (internal data structure), escalate (sync vs async).</a:t>
             </a:r>
           </a:p>
           <a:p>
@@ -3751,7 +3856,7 @@
           <a:p>
             <a:r>
               <a:rPr dirty="0"/>
-              <a:t>If the engineering environment already provides the retry mechanism, follow it. Reinventing retries inside this component is not Design creativity.</a:t>
+              <a:t xml:space="preserve">=====</a:t>
             </a:r>
           </a:p>
           <a:p>
@@ -3760,7 +3865,7 @@
           <a:p>
             <a:r>
               <a:rPr dirty="0"/>
-              <a:t>ANIMATE</a:t>
+              <a:t xml:space="preserve">ANIMATE</a:t>
             </a:r>
           </a:p>
           <a:p>
@@ -3769,7 +3874,7 @@
           <a:p>
             <a:r>
               <a:rPr dirty="0"/>
-              <a:t>If two internal data structures satisfy every inherited property and nothing outside this component cares, choose locally.</a:t>
+              <a:t xml:space="preserve">If the engineering environment already provides the retry mechanism, follow it. Reinventing retries inside this component is not Design creativity.</a:t>
             </a:r>
           </a:p>
           <a:p>
@@ -3778,7 +3883,7 @@
           <a:p>
             <a:r>
               <a:rPr dirty="0"/>
-              <a:t>ANIMATE</a:t>
+              <a:t xml:space="preserve">ANIMATE</a:t>
             </a:r>
           </a:p>
           <a:p>
@@ -3787,7 +3892,7 @@
           <a:p>
             <a:r>
               <a:rPr dirty="0"/>
-              <a:t>But suppose whether we use synchronous or asynchronous coordination changes a system-wide consistency property. That question may have looked open only because Architecture failed to settle something consequential.</a:t>
+              <a:t xml:space="preserve">If two internal data structures satisfy every inherited property and nothing outside this component cares, choose locally.</a:t>
             </a:r>
           </a:p>
           <a:p>
@@ -3796,7 +3901,25 @@
           <a:p>
             <a:r>
               <a:rPr dirty="0"/>
-              <a:t>Design therefore has three moves: follow, choose, or escalate.</a:t>
+              <a:t xml:space="preserve">ANIMATE</a:t>
+            </a:r>
+          </a:p>
+          <a:p>
+            <a:endParaRPr dirty="0"/>
+          </a:p>
+          <a:p>
+            <a:r>
+              <a:rPr dirty="0"/>
+              <a:t xml:space="preserve">But suppose whether we use synchronous or asynchronous coordination changes a system-wide consistency property. That question may have looked open only because Architecture failed to settle something consequential.</a:t>
+            </a:r>
+          </a:p>
+          <a:p>
+            <a:endParaRPr dirty="0"/>
+          </a:p>
+          <a:p>
+            <a:r>
+              <a:rPr dirty="0"/>
+              <a:t xml:space="preserve">Design therefore has three moves: follow, choose, or escalate.</a:t>
             </a:r>
           </a:p>
         </p:txBody>
@@ -3810,7 +3933,7 @@
 </file>
 
 <file path=ppt/notesSlides/notesSlide8.xml><?xml version="1.0" encoding="utf-8"?>
-<p:notes xmlns:a="http://schemas.openxmlformats.org/drawingml/2006/main" xmlns:r="http://schemas.openxmlformats.org/officeDocument/2006/relationships" xmlns:p="http://schemas.openxmlformats.org/presentationml/2006/main">
+<p:notes xmlns:a="http://schemas.openxmlformats.org/drawingml/2006/main" xmlns:p="http://schemas.openxmlformats.org/presentationml/2006/main">
   <p:cSld>
     <p:spTree>
       <p:nvGrpSpPr>
@@ -3856,7 +3979,13 @@
           <a:p>
             <a:r>
               <a:rPr dirty="0"/>
-              <a:t>This gives us the cleanest relationship between the two activities.</a:t>
+              <a:t xml:space="preserve">- Not high-level vs low-level — the relationship is recursive.</a:t>
+            </a:r>
+          </a:p>
+          <a:p>
+            <a:r>
+              <a:rPr dirty="0"/>
+              <a:t xml:space="preserve">- Always: what do we take as given, and what do we decide within it?</a:t>
             </a:r>
           </a:p>
           <a:p>
@@ -3865,7 +3994,7 @@
           <a:p>
             <a:r>
               <a:rPr dirty="0"/>
-              <a:t>Architecture establishes strategy. Design chooses tactics within it.</a:t>
+              <a:t xml:space="preserve">=====</a:t>
             </a:r>
           </a:p>
           <a:p>
@@ -3874,7 +4003,7 @@
           <a:p>
             <a:r>
               <a:rPr dirty="0"/>
-              <a:t>But do not translate that into “Architecture is always high-level and Design is always low-level.” The relationship is recursive.</a:t>
+              <a:t xml:space="preserve">This gives us the cleanest relationship between the two activities.</a:t>
             </a:r>
           </a:p>
           <a:p>
@@ -3883,7 +4012,7 @@
           <a:p>
             <a:r>
               <a:rPr dirty="0"/>
-              <a:t>A subsystem is tactical relative to the system architecture. But if that subsystem is itself too substantial to reason about directly, we may establish an architecture for it before designing its internal parts.</a:t>
+              <a:t xml:space="preserve">Architecture establishes strategy. Design chooses tactics within it.</a:t>
             </a:r>
           </a:p>
           <a:p>
@@ -3892,7 +4021,25 @@
           <a:p>
             <a:r>
               <a:rPr dirty="0"/>
-              <a:t>The question is always: what decisions are we taking as given, and what decisions are we making within them?</a:t>
+              <a:t xml:space="preserve">But do not translate that into “Architecture is always high-level and Design is always low-level.” The relationship is recursive.</a:t>
+            </a:r>
+          </a:p>
+          <a:p>
+            <a:endParaRPr dirty="0"/>
+          </a:p>
+          <a:p>
+            <a:r>
+              <a:rPr dirty="0"/>
+              <a:t xml:space="preserve">A subsystem is tactical relative to the system architecture. But if that subsystem is itself too substantial to reason about directly, we may establish an architecture for it before designing its internal parts.</a:t>
+            </a:r>
+          </a:p>
+          <a:p>
+            <a:endParaRPr dirty="0"/>
+          </a:p>
+          <a:p>
+            <a:r>
+              <a:rPr dirty="0"/>
+              <a:t xml:space="preserve">The question is always: what decisions are we taking as given, and what decisions are we making within them?</a:t>
             </a:r>
           </a:p>
         </p:txBody>
@@ -3906,7 +4053,7 @@
 </file>
 
 <file path=ppt/notesSlides/notesSlide9.xml><?xml version="1.0" encoding="utf-8"?>
-<p:notes xmlns:a="http://schemas.openxmlformats.org/drawingml/2006/main" xmlns:r="http://schemas.openxmlformats.org/officeDocument/2006/relationships" xmlns:p="http://schemas.openxmlformats.org/presentationml/2006/main">
+<p:notes xmlns:a="http://schemas.openxmlformats.org/drawingml/2006/main" xmlns:p="http://schemas.openxmlformats.org/presentationml/2006/main">
   <p:cSld>
     <p:spTree>
       <p:nvGrpSpPr>
@@ -3952,16 +4099,13 @@
           <a:p>
             <a:r>
               <a:rPr dirty="0"/>
-              <a:t>Stop decomposing when the remaining entities are small enough to reason about directly and further decomposition no longer helps. Then Design becomes Implementation.</a:t>
-            </a:r>
-          </a:p>
-          <a:p>
-            <a:endParaRPr dirty="0"/>
+              <a:t xml:space="preserve">- Stop when the remaining entities are small enough to reason about directly; then Design becomes Implementation.</a:t>
+            </a:r>
           </a:p>
           <a:p>
             <a:r>
               <a:rPr dirty="0"/>
-              <a:t>Speaker-note emphasis: “memory”/“object” is intuition, not a literal definition.</a:t>
+              <a:t xml:space="preserve">- Emphasize: “memory” / “object” is intuition, not a literal definition.</a:t>
             </a:r>
           </a:p>
         </p:txBody>
@@ -8122,7 +8266,7 @@
 </file>
 
 <file path=ppt/slides/slide11.xml><?xml version="1.0" encoding="utf-8"?>
-<p:sld xmlns:a="http://schemas.openxmlformats.org/drawingml/2006/main" xmlns:r="http://schemas.openxmlformats.org/officeDocument/2006/relationships" xmlns:p="http://schemas.openxmlformats.org/presentationml/2006/main">
+<p:sld xmlns:a="http://schemas.openxmlformats.org/drawingml/2006/main" xmlns:p="http://schemas.openxmlformats.org/presentationml/2006/main">
   <p:cSld>
     <p:spTree>
       <p:nvGrpSpPr>
@@ -8555,7 +8699,7 @@
               <a:buNone/>
             </a:pPr>
             <a:r>
-              <a:rPr lang="en-US" sz="1150" b="0" i="1" dirty="0">
+              <a:rPr lang="en-US" sz="1200" b="0" i="1" dirty="0">
                 <a:solidFill>
                   <a:srgbClr val="555960"/>
                 </a:solidFill>
@@ -8594,7 +8738,7 @@
               <a:buNone/>
             </a:pPr>
             <a:r>
-              <a:rPr lang="en-US" sz="1150" b="0" i="1" dirty="0">
+              <a:rPr lang="en-US" sz="1200" b="0" i="1" dirty="0">
                 <a:solidFill>
                   <a:srgbClr val="555960"/>
                 </a:solidFill>
@@ -8633,7 +8777,7 @@
               <a:buNone/>
             </a:pPr>
             <a:r>
-              <a:rPr lang="en-US" sz="1150" b="0" i="1" dirty="0">
+              <a:rPr lang="en-US" sz="1200" b="0" i="1" dirty="0">
                 <a:solidFill>
                   <a:srgbClr val="555960"/>
                 </a:solidFill>
@@ -8672,7 +8816,7 @@
               <a:buNone/>
             </a:pPr>
             <a:r>
-              <a:rPr lang="en-US" sz="1150" b="0" i="1" dirty="0">
+              <a:rPr lang="en-US" sz="1200" b="0" i="1" dirty="0">
                 <a:solidFill>
                   <a:srgbClr val="555960"/>
                 </a:solidFill>
@@ -8775,7 +8919,7 @@
               <a:buNone/>
             </a:pPr>
             <a:r>
-              <a:rPr lang="en-US" sz="1100" b="0" i="1" dirty="0">
+              <a:rPr lang="en-US" sz="1200" b="0" i="1" dirty="0">
                 <a:solidFill>
                   <a:srgbClr val="C0392B"/>
                 </a:solidFill>
@@ -8793,8 +8937,8 @@
         </p:nvSpPr>
         <p:spPr>
           <a:xfrm>
-            <a:off x="6080000" y="1980000"/>
-            <a:ext cx="2100000" cy="260000"/>
+            <a:off x="5760720" y="1980000"/>
+            <a:ext cx="2423160" cy="260000"/>
           </a:xfrm>
           <a:prstGeom prst="rect">
             <a:avLst/>
@@ -8814,7 +8958,7 @@
               <a:buNone/>
             </a:pPr>
             <a:r>
-              <a:rPr lang="en-US" sz="1050" b="0" i="1" dirty="0">
+              <a:rPr lang="en-US" sz="1100" b="0" i="1" dirty="0">
                 <a:solidFill>
                   <a:srgbClr val="555960"/>
                 </a:solidFill>
@@ -8917,7 +9061,7 @@
 </file>
 
 <file path=ppt/slides/slide12.xml><?xml version="1.0" encoding="utf-8"?>
-<p:sld xmlns:a="http://schemas.openxmlformats.org/drawingml/2006/main" xmlns:r="http://schemas.openxmlformats.org/officeDocument/2006/relationships" xmlns:p="http://schemas.openxmlformats.org/presentationml/2006/main">
+<p:sld xmlns:a="http://schemas.openxmlformats.org/drawingml/2006/main" xmlns:p="http://schemas.openxmlformats.org/presentationml/2006/main">
   <p:cSld>
     <p:spTree>
       <p:nvGrpSpPr>
@@ -9381,7 +9525,7 @@
               <a:buNone/>
             </a:pPr>
             <a:r>
-              <a:rPr lang="en-US" sz="950" b="0" i="0" dirty="0">
+              <a:rPr lang="en-US" sz="1100" b="0" i="0" dirty="0">
                 <a:solidFill>
                   <a:srgbClr val="5C4826"/>
                 </a:solidFill>
@@ -9451,7 +9595,7 @@
               <a:buNone/>
             </a:pPr>
             <a:r>
-              <a:rPr lang="en-US" sz="950" b="1" i="0" dirty="0">
+              <a:rPr lang="en-US" sz="1100" b="1" i="0" dirty="0">
                 <a:solidFill>
                   <a:srgbClr val="FFFFFF"/>
                 </a:solidFill>
@@ -9521,7 +9665,7 @@
               <a:buNone/>
             </a:pPr>
             <a:r>
-              <a:rPr lang="en-US" sz="950" b="0" i="0" dirty="0">
+              <a:rPr lang="en-US" sz="1100" b="0" i="0" dirty="0">
                 <a:solidFill>
                   <a:srgbClr val="5C4826"/>
                 </a:solidFill>
@@ -9560,7 +9704,7 @@
               <a:buNone/>
             </a:pPr>
             <a:r>
-              <a:rPr lang="en-US" sz="1050" b="0" i="1" dirty="0">
+              <a:rPr lang="en-US" sz="1200" b="0" i="1" dirty="0">
                 <a:solidFill>
                   <a:srgbClr val="8E6F3E"/>
                 </a:solidFill>
@@ -10270,7 +10414,7 @@
 </file>
 
 <file path=ppt/slides/slide14.xml><?xml version="1.0" encoding="utf-8"?>
-<p:sld xmlns:a="http://schemas.openxmlformats.org/drawingml/2006/main" xmlns:r="http://schemas.openxmlformats.org/officeDocument/2006/relationships" xmlns:p="http://schemas.openxmlformats.org/presentationml/2006/main">
+<p:sld xmlns:a="http://schemas.openxmlformats.org/drawingml/2006/main" xmlns:p="http://schemas.openxmlformats.org/presentationml/2006/main">
   <p:cSld>
     <p:spTree>
       <p:nvGrpSpPr>
@@ -10838,7 +10982,7 @@
         </p:nvSpPr>
         <p:spPr>
           <a:xfrm>
-            <a:off x="1240000" y="3450000"/>
+            <a:off x="1240000" y="3502152"/>
             <a:ext cx="6540000" cy="260000"/>
           </a:xfrm>
           <a:prstGeom prst="roundRect">
@@ -10889,7 +11033,7 @@
         </p:nvSpPr>
         <p:spPr>
           <a:xfrm>
-            <a:off x="1071876" y="3760000"/>
+            <a:off x="1071876" y="3977639"/>
             <a:ext cx="7000000" cy="560000"/>
           </a:xfrm>
           <a:prstGeom prst="roundRect">
@@ -13053,7 +13197,7 @@
 </file>
 
 <file path=ppt/slides/slide2.xml><?xml version="1.0" encoding="utf-8"?>
-<p:sld xmlns:a="http://schemas.openxmlformats.org/drawingml/2006/main" xmlns:r="http://schemas.openxmlformats.org/officeDocument/2006/relationships" xmlns:p="http://schemas.openxmlformats.org/presentationml/2006/main">
+<p:sld xmlns:a="http://schemas.openxmlformats.org/drawingml/2006/main" xmlns:p="http://schemas.openxmlformats.org/presentationml/2006/main">
   <p:cSld>
     <p:spTree>
       <p:nvGrpSpPr>
@@ -13266,7 +13410,7 @@
               <a:buNone/>
             </a:pPr>
             <a:r>
-              <a:rPr lang="en-US" sz="1100" b="0" i="1" dirty="0">
+              <a:rPr lang="en-US" sz="1200" b="0" i="1" dirty="0">
                 <a:solidFill>
                   <a:srgbClr val="8E6F3E"/>
                 </a:solidFill>
@@ -13456,7 +13600,7 @@
               <a:buNone/>
             </a:pPr>
             <a:r>
-              <a:rPr lang="en-US" sz="1100" b="0" i="1" dirty="0">
+              <a:rPr lang="en-US" sz="1200" b="0" i="1" dirty="0">
                 <a:solidFill>
                   <a:srgbClr val="8E6F3E"/>
                 </a:solidFill>
@@ -13689,7 +13833,7 @@
               <a:buNone/>
             </a:pPr>
             <a:r>
-              <a:rPr lang="en-US" sz="1100" b="0" i="1" dirty="0">
+              <a:rPr lang="en-US" sz="1200" b="0" i="1" dirty="0">
                 <a:solidFill>
                   <a:srgbClr val="8E6F3E"/>
                 </a:solidFill>
@@ -13728,7 +13872,7 @@
               <a:buNone/>
             </a:pPr>
             <a:r>
-              <a:rPr lang="en-US" sz="1200" b="0" i="1" dirty="0">
+              <a:rPr lang="en-US" sz="1300" b="0" i="1" dirty="0">
                 <a:solidFill>
                   <a:srgbClr val="555960"/>
                 </a:solidFill>
@@ -16896,7 +17040,7 @@
 </file>
 
 <file path=ppt/slides/slide23.xml><?xml version="1.0" encoding="utf-8"?>
-<p:sld xmlns:a="http://schemas.openxmlformats.org/drawingml/2006/main" xmlns:r="http://schemas.openxmlformats.org/officeDocument/2006/relationships" xmlns:p="http://schemas.openxmlformats.org/presentationml/2006/main">
+<p:sld xmlns:a="http://schemas.openxmlformats.org/drawingml/2006/main" xmlns:p="http://schemas.openxmlformats.org/presentationml/2006/main">
   <p:cSld>
     <p:spTree>
       <p:nvGrpSpPr>
@@ -17174,8 +17318,8 @@
         </p:nvSpPr>
         <p:spPr>
           <a:xfrm>
-            <a:off x="400000" y="5080000"/>
-            <a:ext cx="3300000" cy="300000"/>
+            <a:off x="274320" y="5080000"/>
+            <a:ext cx="3703320" cy="300000"/>
           </a:xfrm>
           <a:prstGeom prst="rect">
             <a:avLst/>
@@ -17195,7 +17339,7 @@
               <a:buNone/>
             </a:pPr>
             <a:r>
-              <a:rPr lang="en-US" sz="1050" b="0" i="1" dirty="0">
+              <a:rPr lang="en-US" sz="1100" b="0" i="1" dirty="0">
                 <a:solidFill>
                   <a:srgbClr val="555960"/>
                 </a:solidFill>
@@ -26093,7 +26237,7 @@
 </file>
 
 <file path=ppt/slides/slide36.xml><?xml version="1.0" encoding="utf-8"?>
-<p:sld xmlns:a="http://schemas.openxmlformats.org/drawingml/2006/main" xmlns:r="http://schemas.openxmlformats.org/officeDocument/2006/relationships" xmlns:p="http://schemas.openxmlformats.org/presentationml/2006/main">
+<p:sld xmlns:a="http://schemas.openxmlformats.org/drawingml/2006/main" xmlns:p="http://schemas.openxmlformats.org/presentationml/2006/main">
   <p:cSld>
     <p:spTree>
       <p:nvGrpSpPr>
@@ -26141,7 +26285,7 @@
                   <a:srgbClr val="000000"/>
                 </a:solidFill>
               </a:rPr>
-              <a:t>Architecture constrains the tactics. Design tests the strategy.</a:t>
+              <a:t>Architecture constrains the tactics. Design tests the strategy</a:t>
             </a:r>
           </a:p>
         </p:txBody>
@@ -29911,7 +30055,7 @@
 </file>
 
 <file path=ppt/slides/slide8.xml><?xml version="1.0" encoding="utf-8"?>
-<p:sld xmlns:a="http://schemas.openxmlformats.org/drawingml/2006/main" xmlns:r="http://schemas.openxmlformats.org/officeDocument/2006/relationships" xmlns:p="http://schemas.openxmlformats.org/presentationml/2006/main">
+<p:sld xmlns:a="http://schemas.openxmlformats.org/drawingml/2006/main" xmlns:p="http://schemas.openxmlformats.org/presentationml/2006/main">
   <p:cSld>
     <p:spTree>
       <p:nvGrpSpPr>
@@ -29959,7 +30103,7 @@
                   <a:srgbClr val="000000"/>
                 </a:solidFill>
               </a:rPr>
-              <a:t>Architecture is strategy. Design is tactics.</a:t>
+              <a:t>Architecture is strategy. Design is tactics</a:t>
             </a:r>
           </a:p>
         </p:txBody>

</xml_diff>